<commit_message>
vault backup: 2026-04-02 12:40:09
</commit_message>
<xml_diff>
--- a/00-github-copilot-orientationmap.pptx
+++ b/00-github-copilot-orientationmap.pptx
@@ -2,14 +2,14 @@
 <file path=ppt/presentation.xml><?xml version="1.0" encoding="utf-8"?>
 <p:presentation xmlns:a="http://schemas.openxmlformats.org/drawingml/2006/main" xmlns:r="http://schemas.openxmlformats.org/officeDocument/2006/relationships" xmlns:p="http://schemas.openxmlformats.org/presentationml/2006/main" saveSubsetFonts="1" autoCompressPictures="0">
   <p:sldMasterIdLst>
-    <p:sldMasterId id="2147483660" r:id="rId1"/>
+    <p:sldMasterId id="2147483672" r:id="rId1"/>
   </p:sldMasterIdLst>
   <p:notesMasterIdLst>
     <p:notesMasterId r:id="rId4"/>
   </p:notesMasterIdLst>
   <p:sldIdLst>
-    <p:sldId id="264" r:id="rId2"/>
-    <p:sldId id="269" r:id="rId3"/>
+    <p:sldId id="273" r:id="rId2"/>
+    <p:sldId id="272" r:id="rId3"/>
   </p:sldIdLst>
   <p:sldSz cx="12192000" cy="6858000"/>
   <p:notesSz cx="6858000" cy="9144000"/>
@@ -590,11 +590,7 @@
           <a:p>
             <a:r>
               <a:rPr lang="en-US" dirty="0"/>
-              <a:t>Single is probably the weakest suggestion with the state-of-the-art agents, they’re very good at planning multiple changes and </a:t>
-            </a:r>
-            <a:r>
-              <a:rPr lang="en-US"/>
-              <a:t>tracking progress</a:t>
+              <a:t>Single is probably the weakest suggestion with the state-of-the-art agents, they’re very good at planning multiple changes and tracking progress</a:t>
             </a:r>
           </a:p>
         </p:txBody>
@@ -3540,25 +3536,14 @@
         <p:spPr>
           <a:xfrm>
             <a:off x="0" y="0"/>
-            <a:ext cx="12192000" cy="45720"/>
+            <a:ext cx="12192000" cy="50800"/>
           </a:xfrm>
           <a:prstGeom prst="rect">
             <a:avLst/>
           </a:prstGeom>
-          <a:gradFill>
-            <a:gsLst>
-              <a:gs pos="0">
-                <a:srgbClr val="3FB950"/>
-              </a:gs>
-              <a:gs pos="50000">
-                <a:srgbClr val="58A6FF"/>
-              </a:gs>
-              <a:gs pos="100000">
-                <a:srgbClr val="BC8CFF"/>
-              </a:gs>
-            </a:gsLst>
-            <a:lin ang="0" scaled="1"/>
-          </a:gradFill>
+          <a:solidFill>
+            <a:srgbClr val="58A6FF"/>
+          </a:solidFill>
           <a:ln>
             <a:noFill/>
           </a:ln>
@@ -3580,17 +3565,17 @@
   </p:cSld>
   <p:clrMap bg1="lt1" tx1="dk1" bg2="lt2" tx2="dk2" accent1="accent1" accent2="accent2" accent3="accent3" accent4="accent4" accent5="accent5" accent6="accent6" hlink="hlink" folHlink="folHlink"/>
   <p:sldLayoutIdLst>
-    <p:sldLayoutId id="2147483661" r:id="rId1"/>
-    <p:sldLayoutId id="2147483662" r:id="rId2"/>
-    <p:sldLayoutId id="2147483663" r:id="rId3"/>
-    <p:sldLayoutId id="2147483664" r:id="rId4"/>
-    <p:sldLayoutId id="2147483665" r:id="rId5"/>
-    <p:sldLayoutId id="2147483666" r:id="rId6"/>
-    <p:sldLayoutId id="2147483667" r:id="rId7"/>
-    <p:sldLayoutId id="2147483668" r:id="rId8"/>
-    <p:sldLayoutId id="2147483669" r:id="rId9"/>
-    <p:sldLayoutId id="2147483670" r:id="rId10"/>
-    <p:sldLayoutId id="2147483671" r:id="rId11"/>
+    <p:sldLayoutId id="2147483673" r:id="rId1"/>
+    <p:sldLayoutId id="2147483674" r:id="rId2"/>
+    <p:sldLayoutId id="2147483675" r:id="rId3"/>
+    <p:sldLayoutId id="2147483676" r:id="rId4"/>
+    <p:sldLayoutId id="2147483677" r:id="rId5"/>
+    <p:sldLayoutId id="2147483678" r:id="rId6"/>
+    <p:sldLayoutId id="2147483679" r:id="rId7"/>
+    <p:sldLayoutId id="2147483680" r:id="rId8"/>
+    <p:sldLayoutId id="2147483681" r:id="rId9"/>
+    <p:sldLayoutId id="2147483682" r:id="rId10"/>
+    <p:sldLayoutId id="2147483683" r:id="rId11"/>
   </p:sldLayoutIdLst>
   <p:txStyles>
     <p:titleStyle>
@@ -3604,7 +3589,7 @@
         <a:buNone/>
         <a:defRPr sz="4400" kern="1200">
           <a:solidFill>
-            <a:srgbClr val="E8ECF0"/>
+            <a:srgbClr val="F0F6FC"/>
           </a:solidFill>
           <a:latin typeface="+mj-lt"/>
           <a:ea typeface="+mj-ea"/>
@@ -3894,6 +3879,46 @@
       </p:grpSpPr>
       <p:sp>
         <p:nvSpPr>
+          <p:cNvPr id="45" name="GradientBar"/>
+          <p:cNvSpPr/>
+          <p:nvPr/>
+        </p:nvSpPr>
+        <p:spPr>
+          <a:xfrm>
+            <a:off x="0" y="0"/>
+            <a:ext cx="12192000" cy="50800"/>
+          </a:xfrm>
+          <a:prstGeom prst="rect">
+            <a:avLst/>
+          </a:prstGeom>
+          <a:gradFill>
+            <a:gsLst>
+              <a:gs pos="0">
+                <a:srgbClr val="3FB950"/>
+              </a:gs>
+              <a:gs pos="50000">
+                <a:srgbClr val="58A6FF"/>
+              </a:gs>
+              <a:gs pos="100000">
+                <a:srgbClr val="BC8CFF"/>
+              </a:gs>
+            </a:gsLst>
+            <a:lin ang="0" scaled="1"/>
+          </a:gradFill>
+          <a:ln>
+            <a:noFill/>
+          </a:ln>
+        </p:spPr>
+        <p:txBody>
+          <a:bodyPr/>
+          <a:lstStyle/>
+          <a:p>
+            <a:endParaRPr lang="en-US" dirty="0"/>
+          </a:p>
+        </p:txBody>
+      </p:sp>
+      <p:sp>
+        <p:nvSpPr>
           <p:cNvPr id="10" name="Title"/>
           <p:cNvSpPr/>
           <p:nvPr/>
@@ -3956,8 +3981,10 @@
           <a:solidFill>
             <a:srgbClr val="161B22"/>
           </a:solidFill>
-          <a:ln>
-            <a:noFill/>
+          <a:ln w="12700">
+            <a:solidFill>
+              <a:srgbClr val="30363D"/>
+            </a:solidFill>
           </a:ln>
         </p:spPr>
         <p:txBody>
@@ -3994,11 +4021,11 @@
             </a:avLst>
           </a:prstGeom>
           <a:solidFill>
-            <a:srgbClr val="1F3A24"/>
+            <a:srgbClr val="161B22"/>
           </a:solidFill>
-          <a:ln w="9525">
+          <a:ln w="12700">
             <a:solidFill>
-              <a:srgbClr val="3FB950"/>
+              <a:srgbClr val="30363D"/>
             </a:solidFill>
           </a:ln>
         </p:spPr>
@@ -4048,11 +4075,11 @@
             </a:avLst>
           </a:prstGeom>
           <a:solidFill>
-            <a:srgbClr val="192E45"/>
+            <a:srgbClr val="161B22"/>
           </a:solidFill>
-          <a:ln w="9525">
+          <a:ln w="12700">
             <a:solidFill>
-              <a:srgbClr val="58A6FF"/>
+              <a:srgbClr val="30363D"/>
             </a:solidFill>
           </a:ln>
         </p:spPr>
@@ -4102,11 +4129,11 @@
             </a:avLst>
           </a:prstGeom>
           <a:solidFill>
-            <a:srgbClr val="2A1F42"/>
+            <a:srgbClr val="161B22"/>
           </a:solidFill>
-          <a:ln w="9525">
+          <a:ln w="12700">
             <a:solidFill>
-              <a:srgbClr val="BC8CFF"/>
+              <a:srgbClr val="30363D"/>
             </a:solidFill>
           </a:ln>
         </p:spPr>
@@ -4158,8 +4185,10 @@
           <a:solidFill>
             <a:srgbClr val="161B22"/>
           </a:solidFill>
-          <a:ln>
-            <a:noFill/>
+          <a:ln w="12700">
+            <a:solidFill>
+              <a:srgbClr val="30363D"/>
+            </a:solidFill>
           </a:ln>
         </p:spPr>
         <p:txBody>
@@ -4216,11 +4245,11 @@
             </a:avLst>
           </a:prstGeom>
           <a:solidFill>
-            <a:srgbClr val="1A2E1F"/>
+            <a:srgbClr val="161B22"/>
           </a:solidFill>
-          <a:ln w="6350">
+          <a:ln w="12700">
             <a:solidFill>
-              <a:srgbClr val="3FB950"/>
+              <a:srgbClr val="30363D"/>
             </a:solidFill>
           </a:ln>
         </p:spPr>
@@ -4281,11 +4310,11 @@
             </a:avLst>
           </a:prstGeom>
           <a:solidFill>
-            <a:srgbClr val="15253B"/>
+            <a:srgbClr val="161B22"/>
           </a:solidFill>
-          <a:ln w="6350">
+          <a:ln w="12700">
             <a:solidFill>
-              <a:srgbClr val="58A6FF"/>
+              <a:srgbClr val="30363D"/>
             </a:solidFill>
           </a:ln>
         </p:spPr>
@@ -4346,11 +4375,11 @@
             </a:avLst>
           </a:prstGeom>
           <a:solidFill>
-            <a:srgbClr val="221A35"/>
+            <a:srgbClr val="161B22"/>
           </a:solidFill>
-          <a:ln w="6350">
+          <a:ln w="12700">
             <a:solidFill>
-              <a:srgbClr val="BC8CFF"/>
+              <a:srgbClr val="30363D"/>
             </a:solidFill>
           </a:ln>
         </p:spPr>
@@ -4413,8 +4442,10 @@
           <a:solidFill>
             <a:srgbClr val="161B22"/>
           </a:solidFill>
-          <a:ln>
-            <a:noFill/>
+          <a:ln w="12700">
+            <a:solidFill>
+              <a:srgbClr val="30363D"/>
+            </a:solidFill>
           </a:ln>
         </p:spPr>
         <p:txBody>
@@ -4471,11 +4502,11 @@
             </a:avLst>
           </a:prstGeom>
           <a:solidFill>
-            <a:srgbClr val="1A2E1F"/>
+            <a:srgbClr val="161B22"/>
           </a:solidFill>
-          <a:ln w="6350">
+          <a:ln w="12700">
             <a:solidFill>
-              <a:srgbClr val="3FB950"/>
+              <a:srgbClr val="30363D"/>
             </a:solidFill>
           </a:ln>
         </p:spPr>
@@ -4536,11 +4567,11 @@
             </a:avLst>
           </a:prstGeom>
           <a:solidFill>
-            <a:srgbClr val="15253B"/>
+            <a:srgbClr val="161B22"/>
           </a:solidFill>
-          <a:ln w="6350">
+          <a:ln w="12700">
             <a:solidFill>
-              <a:srgbClr val="58A6FF"/>
+              <a:srgbClr val="30363D"/>
             </a:solidFill>
           </a:ln>
         </p:spPr>
@@ -4601,11 +4632,11 @@
             </a:avLst>
           </a:prstGeom>
           <a:solidFill>
-            <a:srgbClr val="221A35"/>
+            <a:srgbClr val="161B22"/>
           </a:solidFill>
-          <a:ln w="6350">
+          <a:ln w="12700">
             <a:solidFill>
-              <a:srgbClr val="BC8CFF"/>
+              <a:srgbClr val="30363D"/>
             </a:solidFill>
           </a:ln>
         </p:spPr>
@@ -4668,8 +4699,10 @@
           <a:solidFill>
             <a:srgbClr val="161B22"/>
           </a:solidFill>
-          <a:ln>
-            <a:noFill/>
+          <a:ln w="12700">
+            <a:solidFill>
+              <a:srgbClr val="30363D"/>
+            </a:solidFill>
           </a:ln>
         </p:spPr>
         <p:txBody>
@@ -4726,11 +4759,11 @@
             </a:avLst>
           </a:prstGeom>
           <a:solidFill>
-            <a:srgbClr val="1A2E1F"/>
+            <a:srgbClr val="161B22"/>
           </a:solidFill>
-          <a:ln w="6350">
+          <a:ln w="12700">
             <a:solidFill>
-              <a:srgbClr val="3FB950"/>
+              <a:srgbClr val="30363D"/>
             </a:solidFill>
           </a:ln>
         </p:spPr>
@@ -4791,11 +4824,11 @@
             </a:avLst>
           </a:prstGeom>
           <a:solidFill>
-            <a:srgbClr val="15253B"/>
+            <a:srgbClr val="161B22"/>
           </a:solidFill>
-          <a:ln w="6350">
+          <a:ln w="12700">
             <a:solidFill>
-              <a:srgbClr val="58A6FF"/>
+              <a:srgbClr val="30363D"/>
             </a:solidFill>
           </a:ln>
         </p:spPr>
@@ -4856,11 +4889,11 @@
             </a:avLst>
           </a:prstGeom>
           <a:solidFill>
-            <a:srgbClr val="221A35"/>
+            <a:srgbClr val="161B22"/>
           </a:solidFill>
-          <a:ln w="6350">
+          <a:ln w="12700">
             <a:solidFill>
-              <a:srgbClr val="BC8CFF"/>
+              <a:srgbClr val="30363D"/>
             </a:solidFill>
           </a:ln>
         </p:spPr>
@@ -4923,8 +4956,10 @@
           <a:solidFill>
             <a:srgbClr val="161B22"/>
           </a:solidFill>
-          <a:ln>
-            <a:noFill/>
+          <a:ln w="12700">
+            <a:solidFill>
+              <a:srgbClr val="30363D"/>
+            </a:solidFill>
           </a:ln>
         </p:spPr>
         <p:txBody>
@@ -4939,7 +4974,7 @@
             <a:r>
               <a:rPr lang="en-US" sz="1100" b="1" dirty="0">
                 <a:solidFill>
-                  <a:srgbClr val="F78166"/>
+                  <a:srgbClr val="F85149"/>
                 </a:solidFill>
                 <a:latin typeface="Segoe UI Semibold"/>
               </a:rPr>
@@ -4981,11 +5016,11 @@
             </a:avLst>
           </a:prstGeom>
           <a:solidFill>
-            <a:srgbClr val="1A2E1F"/>
+            <a:srgbClr val="161B22"/>
           </a:solidFill>
-          <a:ln w="6350">
+          <a:ln w="12700">
             <a:solidFill>
-              <a:srgbClr val="3FB950"/>
+              <a:srgbClr val="30363D"/>
             </a:solidFill>
           </a:ln>
         </p:spPr>
@@ -5046,11 +5081,11 @@
             </a:avLst>
           </a:prstGeom>
           <a:solidFill>
-            <a:srgbClr val="15253B"/>
+            <a:srgbClr val="161B22"/>
           </a:solidFill>
-          <a:ln w="6350">
+          <a:ln w="12700">
             <a:solidFill>
-              <a:srgbClr val="58A6FF"/>
+              <a:srgbClr val="30363D"/>
             </a:solidFill>
           </a:ln>
         </p:spPr>
@@ -5111,11 +5146,11 @@
             </a:avLst>
           </a:prstGeom>
           <a:solidFill>
-            <a:srgbClr val="221A35"/>
+            <a:srgbClr val="161B22"/>
           </a:solidFill>
-          <a:ln w="6350">
+          <a:ln w="12700">
             <a:solidFill>
-              <a:srgbClr val="BC8CFF"/>
+              <a:srgbClr val="30363D"/>
             </a:solidFill>
           </a:ln>
         </p:spPr>
@@ -5169,7 +5204,7 @@
             <a:r>
               <a:rPr lang="en-US" sz="900" b="1" i="1" dirty="0">
                 <a:solidFill>
-                  <a:srgbClr val="D2A8FF"/>
+                  <a:srgbClr val="BC8CFF"/>
                 </a:solidFill>
                 <a:latin typeface="Segoe UI Semibold"/>
               </a:rPr>
@@ -5303,9 +5338,9 @@
             </a:avLst>
           </a:prstGeom>
           <a:solidFill>
-            <a:srgbClr val="2A1F0D"/>
+            <a:srgbClr val="161B22"/>
           </a:solidFill>
-          <a:ln w="6350">
+          <a:ln w="12700">
             <a:solidFill>
               <a:srgbClr val="D29922"/>
             </a:solidFill>
@@ -5331,7 +5366,7 @@
     </p:spTree>
     <p:extLst>
       <p:ext uri="{BB962C8B-B14F-4D97-AF65-F5344CB8AC3E}">
-        <p14:creationId xmlns:p14="http://schemas.microsoft.com/office/powerpoint/2010/main" val="540434497"/>
+        <p14:creationId xmlns:p14="http://schemas.microsoft.com/office/powerpoint/2010/main" val="3794512638"/>
       </p:ext>
     </p:extLst>
   </p:cSld>
@@ -5385,7 +5420,7 @@
             <a:r>
               <a:rPr lang="en-US" sz="2200" b="1" dirty="0">
                 <a:solidFill>
-                  <a:srgbClr val="E8ECF0"/>
+                  <a:srgbClr val="F0F6FC"/>
                 </a:solidFill>
                 <a:latin typeface="Segoe UI Semibold"/>
               </a:rPr>
@@ -5420,11 +5455,11 @@
             </a:avLst>
           </a:prstGeom>
           <a:solidFill>
-            <a:srgbClr val="1A2E1F"/>
+            <a:srgbClr val="161B22"/>
           </a:solidFill>
-          <a:ln w="9525">
+          <a:ln w="12700">
             <a:solidFill>
-              <a:srgbClr val="3FB950"/>
+              <a:srgbClr val="30363D"/>
             </a:solidFill>
           </a:ln>
         </p:spPr>
@@ -5611,11 +5646,11 @@
             </a:avLst>
           </a:prstGeom>
           <a:solidFill>
-            <a:srgbClr val="15253B"/>
+            <a:srgbClr val="161B22"/>
           </a:solidFill>
-          <a:ln w="9525">
+          <a:ln w="12700">
             <a:solidFill>
-              <a:srgbClr val="58A6FF"/>
+              <a:srgbClr val="30363D"/>
             </a:solidFill>
           </a:ln>
         </p:spPr>
@@ -5802,11 +5837,11 @@
             </a:avLst>
           </a:prstGeom>
           <a:solidFill>
-            <a:srgbClr val="2A1F0D"/>
+            <a:srgbClr val="161B22"/>
           </a:solidFill>
-          <a:ln w="9525">
+          <a:ln w="12700">
             <a:solidFill>
-              <a:srgbClr val="D29922"/>
+              <a:srgbClr val="30363D"/>
             </a:solidFill>
           </a:ln>
         </p:spPr>
@@ -5993,11 +6028,11 @@
             </a:avLst>
           </a:prstGeom>
           <a:solidFill>
-            <a:srgbClr val="221A35"/>
+            <a:srgbClr val="161B22"/>
           </a:solidFill>
-          <a:ln w="9525">
+          <a:ln w="12700">
             <a:solidFill>
-              <a:srgbClr val="BC8CFF"/>
+              <a:srgbClr val="30363D"/>
             </a:solidFill>
           </a:ln>
         </p:spPr>
@@ -6170,7 +6205,7 @@
     </p:spTree>
     <p:extLst>
       <p:ext uri="{BB962C8B-B14F-4D97-AF65-F5344CB8AC3E}">
-        <p14:creationId xmlns:p14="http://schemas.microsoft.com/office/powerpoint/2010/main" val="870173022"/>
+        <p14:creationId xmlns:p14="http://schemas.microsoft.com/office/powerpoint/2010/main" val="2617213405"/>
       </p:ext>
     </p:extLst>
   </p:cSld>
@@ -6181,26 +6216,26 @@
 </file>
 
 <file path=ppt/theme/theme1.xml><?xml version="1.0" encoding="utf-8"?>
-<a:theme xmlns:a="http://schemas.openxmlformats.org/drawingml/2006/main" name="Office Theme [1775079339986]">
+<a:theme xmlns:a="http://schemas.openxmlformats.org/drawingml/2006/main" name="Office Theme [1775084256612]">
   <a:themeElements>
-    <a:clrScheme name="Copilot Matrix">
+    <a:clrScheme name="GitHub Dark">
       <a:dk1>
-        <a:srgbClr val="E8ECF0"/>
+        <a:srgbClr val="F0F6FC"/>
       </a:dk1>
       <a:lt1>
         <a:srgbClr val="0D1117"/>
       </a:lt1>
       <a:dk2>
-        <a:srgbClr val="A0B0C0"/>
+        <a:srgbClr val="C9D1D9"/>
       </a:dk2>
       <a:lt2>
         <a:srgbClr val="161B22"/>
       </a:lt2>
       <a:accent1>
-        <a:srgbClr val="3FB950"/>
+        <a:srgbClr val="58A6FF"/>
       </a:accent1>
       <a:accent2>
-        <a:srgbClr val="58A6FF"/>
+        <a:srgbClr val="3FB950"/>
       </a:accent2>
       <a:accent3>
         <a:srgbClr val="D29922"/>
@@ -6209,7 +6244,7 @@
         <a:srgbClr val="BC8CFF"/>
       </a:accent4>
       <a:accent5>
-        <a:srgbClr val="F78166"/>
+        <a:srgbClr val="F85149"/>
       </a:accent5>
       <a:accent6>
         <a:srgbClr val="79C0FF"/>
@@ -6221,7 +6256,7 @@
         <a:srgbClr val="96607D"/>
       </a:folHlink>
     </a:clrScheme>
-    <a:fontScheme name="Copilot">
+    <a:fontScheme name="GitHub">
       <a:majorFont>
         <a:latin typeface="Segoe UI Semibold" panose="02110004020202020204"/>
         <a:ea typeface=""/>

</xml_diff>

<commit_message>
vault backup: 2026-04-02 13:00:30
</commit_message>
<xml_diff>
--- a/00-github-copilot-orientationmap.pptx
+++ b/00-github-copilot-orientationmap.pptx
@@ -6189,20 +6189,6 @@
 <file path=ppt/slides/slide3.xml><?xml version="1.0" encoding="utf-8"?>
 <p:sld xmlns:a="http://schemas.openxmlformats.org/drawingml/2006/main" xmlns:r="http://schemas.openxmlformats.org/officeDocument/2006/relationships" xmlns:p="http://schemas.openxmlformats.org/presentationml/2006/main">
   <p:cSld>
-    <p:bg>
-      <p:bgPr>
-        <a:xfrm>
-          <a:off x="0" y="0"/>
-          <a:ext cx="12192000" cy="6858000"/>
-        </a:xfrm>
-        <a:prstGeom prst="rect">
-          <a:avLst/>
-        </a:prstGeom>
-        <a:solidFill>
-          <a:srgbClr val="0D1117"/>
-        </a:solidFill>
-      </p:bgPr>
-    </p:bg>
     <p:spTree>
       <p:nvGrpSpPr>
         <p:cNvPr id="1" name=""/>
@@ -6360,6 +6346,7 @@
                   <a:srgbClr val="C9D1D9"/>
                 </a:solidFill>
                 <a:latin typeface="Segoe UI"/>
+                <a:hlinkClick r:id="rId2"/>
               </a:rPr>
               <a:t>→  Getting Started with GitHub Copilot</a:t>
             </a:r>
@@ -6379,6 +6366,7 @@
                   <a:srgbClr val="C9D1D9"/>
                 </a:solidFill>
                 <a:latin typeface="Segoe UI"/>
+                <a:hlinkClick r:id="rId3"/>
               </a:rPr>
               <a:t>→  Build Applications w/ Copilot Agent Mode</a:t>
             </a:r>
@@ -6398,6 +6386,7 @@
                   <a:srgbClr val="C9D1D9"/>
                 </a:solidFill>
                 <a:latin typeface="Segoe UI"/>
+                <a:hlinkClick r:id="rId4"/>
               </a:rPr>
               <a:t>→  Create Applications with Copilot CLI</a:t>
             </a:r>
@@ -6417,6 +6406,7 @@
                   <a:srgbClr val="C9D1D9"/>
                 </a:solidFill>
                 <a:latin typeface="Segoe UI"/>
+                <a:hlinkClick r:id="rId5"/>
               </a:rPr>
               <a:t>→  Expand Your Team with Copilot</a:t>
             </a:r>
@@ -6436,6 +6426,7 @@
                   <a:srgbClr val="C9D1D9"/>
                 </a:solidFill>
                 <a:latin typeface="Segoe UI"/>
+                <a:hlinkClick r:id="rId6"/>
               </a:rPr>
               <a:t>→  Copilot Code Review</a:t>
             </a:r>
@@ -6455,6 +6446,7 @@
                   <a:srgbClr val="C9D1D9"/>
                 </a:solidFill>
                 <a:latin typeface="Segoe UI"/>
+                <a:hlinkClick r:id="rId7"/>
               </a:rPr>
               <a:t>→  Scale Knowledge Using Copilot Spaces</a:t>
             </a:r>
@@ -6474,6 +6466,7 @@
                   <a:srgbClr val="C9D1D9"/>
                 </a:solidFill>
                 <a:latin typeface="Segoe UI"/>
+                <a:hlinkClick r:id="rId8"/>
               </a:rPr>
               <a:t>→  Integrate MCP with Copilot</a:t>
             </a:r>
@@ -6493,6 +6486,7 @@
                   <a:srgbClr val="C9D1D9"/>
                 </a:solidFill>
                 <a:latin typeface="Segoe UI"/>
+                <a:hlinkClick r:id="rId9"/>
               </a:rPr>
               <a:t>→  Customize Your Copilot Experience</a:t>
             </a:r>
@@ -6512,6 +6506,7 @@
                   <a:srgbClr val="C9D1D9"/>
                 </a:solidFill>
                 <a:latin typeface="Segoe UI"/>
+                <a:hlinkClick r:id="rId10"/>
               </a:rPr>
               <a:t>→  Modernize Legacy Code with Copilot</a:t>
             </a:r>
@@ -6531,6 +6526,7 @@
                   <a:srgbClr val="C9D1D9"/>
                 </a:solidFill>
                 <a:latin typeface="Segoe UI"/>
+                <a:hlinkClick r:id="rId11"/>
               </a:rPr>
               <a:t>→  Create AI-Powered Actions</a:t>
             </a:r>
@@ -6628,6 +6624,7 @@
                   <a:srgbClr val="C9D1D9"/>
                 </a:solidFill>
                 <a:latin typeface="Segoe UI"/>
+                <a:hlinkClick r:id="rId12"/>
               </a:rPr>
               <a:t>→  Responsible AI with GitHub Copilot</a:t>
             </a:r>
@@ -6647,6 +6644,7 @@
                   <a:srgbClr val="C9D1D9"/>
                 </a:solidFill>
                 <a:latin typeface="Segoe UI"/>
+                <a:hlinkClick r:id="rId13"/>
               </a:rPr>
               <a:t>→  Prompt Engineering with GitHub Copilot</a:t>
             </a:r>
@@ -6666,6 +6664,7 @@
                   <a:srgbClr val="C9D1D9"/>
                 </a:solidFill>
                 <a:latin typeface="Segoe UI"/>
+                <a:hlinkClick r:id="rId14"/>
               </a:rPr>
               <a:t>→  Introduction to Copilot Spaces</a:t>
             </a:r>
@@ -6685,6 +6684,7 @@
                   <a:srgbClr val="C9D1D9"/>
                 </a:solidFill>
                 <a:latin typeface="Segoe UI"/>
+                <a:hlinkClick r:id="rId15"/>
               </a:rPr>
               <a:t>→  Create Unit Tests with Copilot</a:t>
             </a:r>
@@ -6704,6 +6704,7 @@
                   <a:srgbClr val="C9D1D9"/>
                 </a:solidFill>
                 <a:latin typeface="Segoe UI"/>
+                <a:hlinkClick r:id="rId16"/>
               </a:rPr>
               <a:t>→  GitHub Copilot and Productivity</a:t>
             </a:r>
@@ -6723,6 +6724,7 @@
                   <a:srgbClr val="C9D1D9"/>
                 </a:solidFill>
                 <a:latin typeface="Segoe UI"/>
+                <a:hlinkClick r:id="rId17"/>
               </a:rPr>
               <a:t>→  Copilot Across Environments</a:t>
             </a:r>
@@ -6742,6 +6744,7 @@
                   <a:srgbClr val="C9D1D9"/>
                 </a:solidFill>
                 <a:latin typeface="Segoe UI"/>
+                <a:hlinkClick r:id="rId18"/>
               </a:rPr>
               <a:t>→  Management and Customization</a:t>
             </a:r>
@@ -6784,6 +6787,7 @@
                   <a:srgbClr val="C9D1D9"/>
                 </a:solidFill>
                 <a:latin typeface="Segoe UI"/>
+                <a:hlinkClick r:id="rId19"/>
               </a:rPr>
               <a:t>→  Copilot Coding Agent</a:t>
             </a:r>
@@ -6803,6 +6807,7 @@
                   <a:srgbClr val="C9D1D9"/>
                 </a:solidFill>
                 <a:latin typeface="Segoe UI"/>
+                <a:hlinkClick r:id="rId20"/>
               </a:rPr>
               <a:t>→  GitHub MCP Server</a:t>
             </a:r>
@@ -6822,6 +6827,7 @@
                   <a:srgbClr val="C9D1D9"/>
                 </a:solidFill>
                 <a:latin typeface="Segoe UI"/>
+                <a:hlinkClick r:id="rId21"/>
               </a:rPr>
               <a:t>→  Code Review with Copilot</a:t>
             </a:r>
@@ -6870,18 +6876,6 @@
 <file path=ppt/slides/slide4.xml><?xml version="1.0" encoding="utf-8"?>
 <p:sld xmlns:a="http://schemas.openxmlformats.org/drawingml/2006/main" xmlns:r="http://schemas.openxmlformats.org/officeDocument/2006/relationships" xmlns:p="http://schemas.openxmlformats.org/presentationml/2006/main">
   <p:cSld>
-    <p:bg>
-      <p:bgPr>
-        <a:xfrm>
-          <a:off x="0" y="0"/>
-          <a:ext cx="12192000" cy="6858000"/>
-        </a:xfrm>
-        <a:prstGeom prst="rect">
-          <a:avLst/>
-        </a:prstGeom>
-        <a:noFill/>
-      </p:bgPr>
-    </p:bg>
     <p:spTree>
       <p:nvGrpSpPr>
         <p:cNvPr id="1" name=""/>
@@ -7133,6 +7127,7 @@
                   <a:srgbClr val="58A6FF"/>
                 </a:solidFill>
                 <a:latin typeface="Segoe UI"/>
+                <a:hlinkClick r:id="rId2"/>
               </a:rPr>
               <a:t>github.com/skills/getting-started-with-github-copilot</a:t>
             </a:r>
@@ -7288,6 +7283,7 @@
                   <a:srgbClr val="58A6FF"/>
                 </a:solidFill>
                 <a:latin typeface="Segoe UI"/>
+                <a:hlinkClick r:id="rId3"/>
               </a:rPr>
               <a:t>github.com/skills/create-applications-with-the-copilot-cli</a:t>
             </a:r>
@@ -7443,6 +7439,7 @@
                   <a:srgbClr val="58A6FF"/>
                 </a:solidFill>
                 <a:latin typeface="Segoe UI"/>
+                <a:hlinkClick r:id="rId4"/>
               </a:rPr>
               <a:t>github.com/skills/customize-your-github-copilot-experience</a:t>
             </a:r>
@@ -7619,6 +7616,7 @@
                   <a:srgbClr val="8B949E"/>
                 </a:solidFill>
                 <a:latin typeface="Segoe UI"/>
+                <a:hlinkClick r:id="rId2"/>
               </a:rPr>
               <a:t>skills/build-applications-w-copilot-agent-mode</a:t>
             </a:r>
@@ -7725,6 +7723,7 @@
                   <a:srgbClr val="8B949E"/>
                 </a:solidFill>
                 <a:latin typeface="Segoe UI"/>
+                <a:hlinkClick r:id="rId3"/>
               </a:rPr>
               <a:t>skills/expand-your-team-with-copilot</a:t>
             </a:r>
@@ -7831,6 +7830,7 @@
                   <a:srgbClr val="8B949E"/>
                 </a:solidFill>
                 <a:latin typeface="Segoe UI"/>
+                <a:hlinkClick r:id="rId4"/>
               </a:rPr>
               <a:t>skills/copilot-code-review</a:t>
             </a:r>
@@ -7937,6 +7937,7 @@
                   <a:srgbClr val="8B949E"/>
                 </a:solidFill>
                 <a:latin typeface="Segoe UI"/>
+                <a:hlinkClick r:id="rId5"/>
               </a:rPr>
               <a:t>skills/scale-institutional-knowledge-using-copilot-spaces</a:t>
             </a:r>
@@ -8043,6 +8044,7 @@
                   <a:srgbClr val="8B949E"/>
                 </a:solidFill>
                 <a:latin typeface="Segoe UI"/>
+                <a:hlinkClick r:id="rId6"/>
               </a:rPr>
               <a:t>skills/integrate-mcp-with-copilot</a:t>
             </a:r>
@@ -8149,6 +8151,7 @@
                   <a:srgbClr val="8B949E"/>
                 </a:solidFill>
                 <a:latin typeface="Segoe UI"/>
+                <a:hlinkClick r:id="rId7"/>
               </a:rPr>
               <a:t>skills/modernize-your-legacy-code-with-github-copilot</a:t>
             </a:r>
@@ -8255,6 +8258,7 @@
                   <a:srgbClr val="8B949E"/>
                 </a:solidFill>
                 <a:latin typeface="Segoe UI"/>
+                <a:hlinkClick r:id="rId8"/>
               </a:rPr>
               <a:t>skills/create-ai-powered-actions</a:t>
             </a:r>
@@ -8272,16 +8276,6 @@
 <file path=ppt/slides/slide6.xml><?xml version="1.0" encoding="utf-8"?>
 <p:sld xmlns:a="http://schemas.openxmlformats.org/drawingml/2006/main" xmlns:r="http://schemas.openxmlformats.org/officeDocument/2006/relationships" xmlns:p="http://schemas.openxmlformats.org/presentationml/2006/main">
   <p:cSld>
-    <p:bg>
-      <p:bgPr>
-        <a:xfrm>
-          <a:off x="0" y="0"/>
-          <a:ext cx="12192000" cy="6858000"/>
-        </a:xfrm>
-        <a:prstFill prst="solidFill"/>
-        <a:effectLst/>
-      </p:bgPr>
-    </p:bg>
     <p:spTree>
       <p:nvGrpSpPr>
         <p:cNvPr id="1" name=""/>
@@ -8371,6 +8365,7 @@
                   <a:srgbClr val="58A6FF"/>
                 </a:solidFill>
                 <a:latin typeface="Segoe UI"/>
+                <a:hlinkClick r:id="rId2"/>
               </a:rPr>
               <a:t>learn.microsoft.com/training/paths/copilot/</a:t>
             </a:r>
@@ -8426,6 +8421,7 @@
                   <a:srgbClr val="E8ECF0"/>
                 </a:solidFill>
                 <a:latin typeface="Segoe UI Semibold"/>
+                <a:hlinkClick r:id="rId3"/>
               </a:rPr>
               <a:t xml:space="preserve">  Responsible AI with GitHub Copilot</a:t>
             </a:r>
@@ -8533,6 +8529,7 @@
                   <a:srgbClr val="E8ECF0"/>
                 </a:solidFill>
                 <a:latin typeface="Segoe UI Semibold"/>
+                <a:hlinkClick r:id="rId4"/>
               </a:rPr>
               <a:t xml:space="preserve">  Prompt Engineering with GitHub Copilot</a:t>
             </a:r>
@@ -8640,6 +8637,7 @@
                   <a:srgbClr val="E8ECF0"/>
                 </a:solidFill>
                 <a:latin typeface="Segoe UI Semibold"/>
+                <a:hlinkClick r:id="rId5"/>
               </a:rPr>
               <a:t xml:space="preserve">  Introduction to Copilot Spaces</a:t>
             </a:r>
@@ -8747,6 +8745,7 @@
                   <a:srgbClr val="E8ECF0"/>
                 </a:solidFill>
                 <a:latin typeface="Segoe UI Semibold"/>
+                <a:hlinkClick r:id="rId6"/>
               </a:rPr>
               <a:t xml:space="preserve">  Create Unit Tests with GitHub Copilot</a:t>
             </a:r>
@@ -8854,6 +8853,7 @@
                   <a:srgbClr val="E8ECF0"/>
                 </a:solidFill>
                 <a:latin typeface="Segoe UI Semibold"/>
+                <a:hlinkClick r:id="rId7"/>
               </a:rPr>
               <a:t xml:space="preserve">  GitHub Copilot and Productivity</a:t>
             </a:r>
@@ -8961,6 +8961,7 @@
                   <a:srgbClr val="E8ECF0"/>
                 </a:solidFill>
                 <a:latin typeface="Segoe UI Semibold"/>
+                <a:hlinkClick r:id="rId8"/>
               </a:rPr>
               <a:t xml:space="preserve">  GitHub Copilot Across Environments</a:t>
             </a:r>
@@ -9068,6 +9069,7 @@
                   <a:srgbClr val="E8ECF0"/>
                 </a:solidFill>
                 <a:latin typeface="Segoe UI Semibold"/>
+                <a:hlinkClick r:id="rId9"/>
               </a:rPr>
               <a:t xml:space="preserve">  Management and Customization</a:t>
             </a:r>
@@ -9137,16 +9139,6 @@
 <file path=ppt/slides/slide7.xml><?xml version="1.0" encoding="utf-8"?>
 <p:sld xmlns:a="http://schemas.openxmlformats.org/drawingml/2006/main" xmlns:r="http://schemas.openxmlformats.org/officeDocument/2006/relationships" xmlns:p="http://schemas.openxmlformats.org/presentationml/2006/main">
   <p:cSld>
-    <p:bg>
-      <p:bgPr>
-        <a:xfrm>
-          <a:off x="0" y="0"/>
-          <a:ext cx="12192000" cy="6858000"/>
-        </a:xfrm>
-        <a:prstFill prst="solidFill"/>
-        <a:effectLst/>
-      </p:bgPr>
-    </p:bg>
     <p:spTree>
       <p:nvGrpSpPr>
         <p:cNvPr id="1" name=""/>
@@ -9236,6 +9228,7 @@
                   <a:srgbClr val="58A6FF"/>
                 </a:solidFill>
                 <a:latin typeface="Segoe UI"/>
+                <a:hlinkClick r:id="rId2"/>
               </a:rPr>
               <a:t>learn.microsoft.com/training/paths/gh-copilot-2/</a:t>
             </a:r>
@@ -9860,18 +9853,6 @@
 <file path=ppt/slides/slide8.xml><?xml version="1.0" encoding="utf-8"?>
 <p:sld xmlns:a="http://schemas.openxmlformats.org/drawingml/2006/main" xmlns:r="http://schemas.openxmlformats.org/officeDocument/2006/relationships" xmlns:p="http://schemas.openxmlformats.org/presentationml/2006/main">
   <p:cSld>
-    <p:bg>
-      <p:bgPr>
-        <a:xfrm>
-          <a:off x="0" y="0"/>
-          <a:ext cx="12192000" cy="6858000"/>
-        </a:xfrm>
-        <a:prstGeom prst="rect">
-          <a:avLst/>
-        </a:prstGeom>
-        <a:noFill/>
-      </p:bgPr>
-    </p:bg>
     <p:spTree>
       <p:nvGrpSpPr>
         <p:cNvPr id="1" name=""/>
@@ -11005,6 +10986,7 @@
                   <a:srgbClr val="8B949E"/>
                 </a:solidFill>
                 <a:latin typeface="Segoe UI"/>
+                <a:hlinkClick r:id="rId2"/>
               </a:rPr>
               <a:t>All resources: learn.github.com/skills  |  learn.microsoft.com/training/paths/copilot/</a:t>
             </a:r>

</xml_diff>

<commit_message>
vault backup: 2026-04-02 15:12:08
</commit_message>
<xml_diff>
--- a/00-github-copilot-orientationmap.pptx
+++ b/00-github-copilot-orientationmap.pptx
@@ -4,6 +4,9 @@
   <p:sldMasterIdLst>
     <p:sldMasterId id="2147483648" r:id="rId1"/>
   </p:sldMasterIdLst>
+  <p:notesMasterIdLst>
+    <p:notesMasterId r:id="rId10"/>
+  </p:notesMasterIdLst>
   <p:sldIdLst>
     <p:sldId id="256" r:id="rId2"/>
     <p:sldId id="257" r:id="rId3"/>
@@ -14,9 +17,6 @@
     <p:sldId id="262" r:id="rId8"/>
     <p:sldId id="263" r:id="rId9"/>
   </p:sldIdLst>
-  <p:notesMasterIdLst>
-    <p:notesMasterId r:id="rId10"/>
-  </p:notesMasterIdLst>
   <p:sldSz cx="12192000" cy="6858000"/>
   <p:notesSz cx="6858000" cy="12192000"/>
   <p:defaultTextStyle>
@@ -1476,14 +1476,7 @@
 
 <file path=ppt/slides/slide1.xml><?xml version="1.0" encoding="utf-8"?>
 <p:sld xmlns:a="http://schemas.openxmlformats.org/drawingml/2006/main" xmlns:r="http://schemas.openxmlformats.org/officeDocument/2006/relationships" xmlns:p="http://schemas.openxmlformats.org/presentationml/2006/main">
-  <p:cSld name="Slide 1">
-    <p:bg>
-      <p:bgPr>
-        <a:solidFill>
-          <a:srgbClr val="0D1117"/>
-        </a:solidFill>
-      </p:bgPr>
-    </p:bg>
+  <p:cSld>
     <p:spTree>
       <p:nvGrpSpPr>
         <p:cNvPr id="1" name=""/>
@@ -1500,2123 +1493,1425 @@
       </p:grpSpPr>
       <p:sp>
         <p:nvSpPr>
-          <p:cNvPr id="2" name="Shape 0"/>
+          <p:cNvPr id="10" name="Title"/>
+          <p:cNvSpPr/>
+          <p:nvPr/>
+        </p:nvSpPr>
+        <p:spPr>
+          <a:xfrm>
+            <a:off x="457200" y="127000"/>
+            <a:ext cx="11277600" cy="558800"/>
+          </a:xfrm>
+          <a:prstGeom prst="rect">
+            <a:avLst/>
+          </a:prstGeom>
+          <a:noFill/>
+          <a:ln>
+            <a:noFill/>
+          </a:ln>
+        </p:spPr>
+        <p:txBody>
+          <a:bodyPr wrap="square" lIns="54000" tIns="36000" rIns="54000" bIns="36000" anchor="ctr"/>
+          <a:lstStyle/>
+          <a:p>
+            <a:pPr algn="l"/>
+            <a:r>
+              <a:rPr lang="en-US" sz="2200" b="1" dirty="0">
+                <a:solidFill>
+                  <a:srgbClr val="3FB950"/>
+                </a:solidFill>
+                <a:latin typeface="Segoe UI Semibold"/>
+              </a:rPr>
+              <a:t>GitHub Copilot Proficiency Matrix</a:t>
+            </a:r>
+            <a:r>
+              <a:rPr lang="en-US" sz="1400" dirty="0">
+                <a:solidFill>
+                  <a:srgbClr val="8B949E"/>
+                </a:solidFill>
+                <a:latin typeface="Segoe UI"/>
+              </a:rPr>
+              <a:t xml:space="preserve">  |  Feature Threads × Advancement Zones</a:t>
+            </a:r>
+          </a:p>
+        </p:txBody>
+      </p:sp>
+      <p:sp>
+        <p:nvSpPr>
+          <p:cNvPr id="11" name="CornerCell"/>
+          <p:cNvSpPr/>
+          <p:nvPr/>
+        </p:nvSpPr>
+        <p:spPr>
+          <a:xfrm>
+            <a:off x="457200" y="787400"/>
+            <a:ext cx="1860804" cy="482600"/>
+          </a:xfrm>
+          <a:prstGeom prst="roundRect">
+            <a:avLst>
+              <a:gd name="adj" fmla="val 5000"/>
+            </a:avLst>
+          </a:prstGeom>
+          <a:ln w="12700">
+            <a:solidFill>
+              <a:srgbClr val="30363D"/>
+            </a:solidFill>
+          </a:ln>
+        </p:spPr>
+        <p:txBody>
+          <a:bodyPr wrap="square" lIns="54000" tIns="36000" rIns="54000" bIns="36000" anchor="ctr"/>
+          <a:lstStyle/>
+          <a:p>
+            <a:pPr algn="ctr"/>
+            <a:r>
+              <a:rPr lang="en-US" sz="1000" dirty="0">
+                <a:solidFill>
+                  <a:srgbClr val="8B949E"/>
+                </a:solidFill>
+                <a:latin typeface="Segoe UI"/>
+              </a:rPr>
+              <a:t>FEATURE →</a:t>
+            </a:r>
+          </a:p>
+        </p:txBody>
+      </p:sp>
+      <p:sp>
+        <p:nvSpPr>
+          <p:cNvPr id="12" name="ZoneHeader1"/>
+          <p:cNvSpPr/>
+          <p:nvPr/>
+        </p:nvSpPr>
+        <p:spPr>
+          <a:xfrm>
+            <a:off x="2343404" y="787400"/>
+            <a:ext cx="3088132" cy="482600"/>
+          </a:xfrm>
+          <a:prstGeom prst="roundRect">
+            <a:avLst>
+              <a:gd name="adj" fmla="val 5000"/>
+            </a:avLst>
+          </a:prstGeom>
+          <a:ln w="12700">
+            <a:solidFill>
+              <a:srgbClr val="30363D"/>
+            </a:solidFill>
+          </a:ln>
+        </p:spPr>
+        <p:txBody>
+          <a:bodyPr wrap="square" lIns="54000" tIns="36000" rIns="54000" bIns="36000" anchor="ctr"/>
+          <a:lstStyle/>
+          <a:p>
+            <a:pPr algn="ctr"/>
+            <a:r>
+              <a:rPr lang="en-US" sz="1400" b="1" dirty="0">
+                <a:solidFill>
+                  <a:srgbClr val="3FB950"/>
+                </a:solidFill>
+                <a:latin typeface="Segoe UI Semibold"/>
+              </a:rPr>
+              <a:t>Zone 1: Foundational</a:t>
+            </a:r>
+          </a:p>
+          <a:p>
+            <a:pPr algn="ctr"/>
+            <a:r>
+              <a:rPr lang="en-US" sz="900" dirty="0">
+                <a:solidFill>
+                  <a:srgbClr val="8B949E"/>
+                </a:solidFill>
+                <a:latin typeface="Segoe UI"/>
+              </a:rPr>
+              <a:t>Assistive • IDE Editor Level</a:t>
+            </a:r>
+          </a:p>
+        </p:txBody>
+      </p:sp>
+      <p:sp>
+        <p:nvSpPr>
+          <p:cNvPr id="13" name="ZoneHeader2"/>
+          <p:cNvSpPr/>
+          <p:nvPr/>
+        </p:nvSpPr>
+        <p:spPr>
+          <a:xfrm>
+            <a:off x="5482336" y="787400"/>
+            <a:ext cx="3088132" cy="482600"/>
+          </a:xfrm>
+          <a:prstGeom prst="roundRect">
+            <a:avLst>
+              <a:gd name="adj" fmla="val 5000"/>
+            </a:avLst>
+          </a:prstGeom>
+          <a:ln w="12700">
+            <a:solidFill>
+              <a:srgbClr val="30363D"/>
+            </a:solidFill>
+          </a:ln>
+        </p:spPr>
+        <p:txBody>
+          <a:bodyPr wrap="square" lIns="54000" tIns="36000" rIns="54000" bIns="36000" anchor="ctr"/>
+          <a:lstStyle/>
+          <a:p>
+            <a:pPr algn="ctr"/>
+            <a:r>
+              <a:rPr lang="en-US" sz="1400" b="1" dirty="0">
+                <a:solidFill>
+                  <a:srgbClr val="58A6FF"/>
+                </a:solidFill>
+                <a:latin typeface="Segoe UI Semibold"/>
+              </a:rPr>
+              <a:t>Zone 2: Intermediate</a:t>
+            </a:r>
+          </a:p>
+          <a:p>
+            <a:pPr algn="ctr"/>
+            <a:r>
+              <a:rPr lang="en-US" sz="900" dirty="0">
+                <a:solidFill>
+                  <a:srgbClr val="8B949E"/>
+                </a:solidFill>
+                <a:latin typeface="Segoe UI"/>
+              </a:rPr>
+              <a:t>Collaborative • Repository/Team Level</a:t>
+            </a:r>
+          </a:p>
+        </p:txBody>
+      </p:sp>
+      <p:sp>
+        <p:nvSpPr>
+          <p:cNvPr id="14" name="ZoneHeader3"/>
+          <p:cNvSpPr/>
+          <p:nvPr/>
+        </p:nvSpPr>
+        <p:spPr>
+          <a:xfrm>
+            <a:off x="8621268" y="787400"/>
+            <a:ext cx="3088132" cy="482600"/>
+          </a:xfrm>
+          <a:prstGeom prst="roundRect">
+            <a:avLst>
+              <a:gd name="adj" fmla="val 5000"/>
+            </a:avLst>
+          </a:prstGeom>
+          <a:ln w="12700">
+            <a:solidFill>
+              <a:srgbClr val="30363D"/>
+            </a:solidFill>
+          </a:ln>
+        </p:spPr>
+        <p:txBody>
+          <a:bodyPr wrap="square" lIns="54000" tIns="36000" rIns="54000" bIns="36000" anchor="ctr"/>
+          <a:lstStyle/>
+          <a:p>
+            <a:pPr algn="ctr"/>
+            <a:r>
+              <a:rPr lang="en-US" sz="1400" b="1" dirty="0">
+                <a:solidFill>
+                  <a:srgbClr val="BC8CFF"/>
+                </a:solidFill>
+                <a:latin typeface="Segoe UI Semibold"/>
+              </a:rPr>
+              <a:t>Zone 3: Advanced</a:t>
+            </a:r>
+          </a:p>
+          <a:p>
+            <a:pPr algn="ctr"/>
+            <a:r>
+              <a:rPr lang="en-US" sz="900" dirty="0">
+                <a:solidFill>
+                  <a:srgbClr val="8B949E"/>
+                </a:solidFill>
+                <a:latin typeface="Segoe UI"/>
+              </a:rPr>
+              <a:t>Agentic • Architect/Org Level</a:t>
+            </a:r>
+          </a:p>
+        </p:txBody>
+      </p:sp>
+      <p:sp>
+        <p:nvSpPr>
+          <p:cNvPr id="15" name="FeatureLabel1"/>
+          <p:cNvSpPr/>
+          <p:nvPr/>
+        </p:nvSpPr>
+        <p:spPr>
+          <a:xfrm>
+            <a:off x="457200" y="1308100"/>
+            <a:ext cx="1835404" cy="1206500"/>
+          </a:xfrm>
+          <a:prstGeom prst="roundRect">
+            <a:avLst>
+              <a:gd name="adj" fmla="val 5000"/>
+            </a:avLst>
+          </a:prstGeom>
+          <a:ln w="12700">
+            <a:solidFill>
+              <a:srgbClr val="30363D"/>
+            </a:solidFill>
+          </a:ln>
+        </p:spPr>
+        <p:txBody>
+          <a:bodyPr wrap="square" lIns="54000" tIns="36000" rIns="54000" bIns="36000" anchor="ctr"/>
+          <a:lstStyle/>
+          <a:p>
+            <a:pPr algn="ctr">
+              <a:lnSpc>
+                <a:spcPts val="1200"/>
+              </a:lnSpc>
+            </a:pPr>
+            <a:r>
+              <a:rPr lang="en-US" sz="1100" b="1" dirty="0">
+                <a:solidFill>
+                  <a:srgbClr val="3FB950"/>
+                </a:solidFill>
+                <a:latin typeface="Segoe UI Semibold"/>
+              </a:rPr>
+              <a:t>IDE Workflow</a:t>
+            </a:r>
+          </a:p>
+          <a:p>
+            <a:pPr algn="ctr">
+              <a:lnSpc>
+                <a:spcPts val="1000"/>
+              </a:lnSpc>
+            </a:pPr>
+            <a:r>
+              <a:rPr lang="en-US" sz="800" i="1" dirty="0">
+                <a:solidFill>
+                  <a:srgbClr val="8B949E"/>
+                </a:solidFill>
+                <a:latin typeface="Segoe UI"/>
+              </a:rPr>
+              <a:t>The Editor</a:t>
+            </a:r>
+          </a:p>
+        </p:txBody>
+      </p:sp>
+      <p:sp>
+        <p:nvSpPr>
+          <p:cNvPr id="16" name="Cell_1_1"/>
+          <p:cNvSpPr/>
+          <p:nvPr/>
+        </p:nvSpPr>
+        <p:spPr>
+          <a:xfrm>
+            <a:off x="2343404" y="1308100"/>
+            <a:ext cx="3088132" cy="1206500"/>
+          </a:xfrm>
+          <a:prstGeom prst="roundRect">
+            <a:avLst>
+              <a:gd name="adj" fmla="val 5000"/>
+            </a:avLst>
+          </a:prstGeom>
+          <a:ln w="12700">
+            <a:solidFill>
+              <a:srgbClr val="30363D"/>
+            </a:solidFill>
+          </a:ln>
+        </p:spPr>
+        <p:txBody>
+          <a:bodyPr wrap="square" lIns="54000" tIns="36000" rIns="54000" bIns="36000" anchor="ctr"/>
+          <a:lstStyle/>
+          <a:p>
+            <a:pPr algn="l">
+              <a:lnSpc>
+                <a:spcPts val="1200"/>
+              </a:lnSpc>
+              <a:spcAft>
+                <a:spcPts val="200"/>
+              </a:spcAft>
+            </a:pPr>
+            <a:r>
+              <a:rPr lang="en-US" sz="1000" b="1" dirty="0">
+                <a:solidFill>
+                  <a:srgbClr val="3FB950"/>
+                </a:solidFill>
+                <a:latin typeface="Segoe UI Semibold"/>
+              </a:rPr>
+              <a:t>Ghost Text</a:t>
+            </a:r>
+          </a:p>
+          <a:p>
+            <a:pPr algn="l">
+              <a:lnSpc>
+                <a:spcPts val="1100"/>
+              </a:lnSpc>
+            </a:pPr>
+            <a:r>
+              <a:rPr lang="en-US" sz="900" dirty="0">
+                <a:solidFill>
+                  <a:srgbClr val="C9D1D9"/>
+                </a:solidFill>
+                <a:latin typeface="Segoe UI"/>
+              </a:rPr>
+              <a:t>Inline code and comment completion</a:t>
+            </a:r>
+          </a:p>
+        </p:txBody>
+      </p:sp>
+      <p:sp>
+        <p:nvSpPr>
+          <p:cNvPr id="17" name="Cell_1_2"/>
+          <p:cNvSpPr/>
+          <p:nvPr/>
+        </p:nvSpPr>
+        <p:spPr>
+          <a:xfrm>
+            <a:off x="5482336" y="1308100"/>
+            <a:ext cx="3088132" cy="1206500"/>
+          </a:xfrm>
+          <a:prstGeom prst="roundRect">
+            <a:avLst>
+              <a:gd name="adj" fmla="val 5000"/>
+            </a:avLst>
+          </a:prstGeom>
+          <a:ln w="12700">
+            <a:solidFill>
+              <a:srgbClr val="30363D"/>
+            </a:solidFill>
+          </a:ln>
+        </p:spPr>
+        <p:txBody>
+          <a:bodyPr wrap="square" lIns="54000" tIns="36000" rIns="54000" bIns="36000" anchor="ctr"/>
+          <a:lstStyle/>
+          <a:p>
+            <a:pPr algn="l">
+              <a:lnSpc>
+                <a:spcPts val="1200"/>
+              </a:lnSpc>
+              <a:spcAft>
+                <a:spcPts val="200"/>
+              </a:spcAft>
+            </a:pPr>
+            <a:r>
+              <a:rPr lang="en-US" sz="1000" b="1" dirty="0">
+                <a:solidFill>
+                  <a:srgbClr val="58A6FF"/>
+                </a:solidFill>
+                <a:latin typeface="Segoe UI Semibold"/>
+              </a:rPr>
+              <a:t>Chat &amp; Workspace</a:t>
+            </a:r>
+          </a:p>
+          <a:p>
+            <a:pPr algn="l">
+              <a:lnSpc>
+                <a:spcPts val="1100"/>
+              </a:lnSpc>
+            </a:pPr>
+            <a:r>
+              <a:rPr lang="en-US" sz="900" dirty="0">
+                <a:solidFill>
+                  <a:srgbClr val="C9D1D9"/>
+                </a:solidFill>
+                <a:latin typeface="Segoe UI"/>
+              </a:rPr>
+              <a:t>Multi-file context via @workspace. /explain and /tests commands</a:t>
+            </a:r>
+          </a:p>
+        </p:txBody>
+      </p:sp>
+      <p:sp>
+        <p:nvSpPr>
+          <p:cNvPr id="18" name="Cell_1_3"/>
+          <p:cNvSpPr/>
+          <p:nvPr/>
+        </p:nvSpPr>
+        <p:spPr>
+          <a:xfrm>
+            <a:off x="8621268" y="1308100"/>
+            <a:ext cx="3088132" cy="1206500"/>
+          </a:xfrm>
+          <a:prstGeom prst="roundRect">
+            <a:avLst>
+              <a:gd name="adj" fmla="val 5000"/>
+            </a:avLst>
+          </a:prstGeom>
+          <a:ln w="12700">
+            <a:solidFill>
+              <a:srgbClr val="30363D"/>
+            </a:solidFill>
+          </a:ln>
+        </p:spPr>
+        <p:txBody>
+          <a:bodyPr wrap="square" lIns="54000" tIns="36000" rIns="54000" bIns="36000" anchor="ctr"/>
+          <a:lstStyle/>
+          <a:p>
+            <a:pPr algn="l">
+              <a:lnSpc>
+                <a:spcPts val="1200"/>
+              </a:lnSpc>
+              <a:spcAft>
+                <a:spcPts val="200"/>
+              </a:spcAft>
+            </a:pPr>
+            <a:r>
+              <a:rPr lang="en-US" sz="1000" b="1" dirty="0">
+                <a:solidFill>
+                  <a:srgbClr val="BC8CFF"/>
+                </a:solidFill>
+                <a:latin typeface="Segoe UI Semibold"/>
+              </a:rPr>
+              <a:t>Copilot Spaces</a:t>
+            </a:r>
+          </a:p>
+          <a:p>
+            <a:pPr algn="l">
+              <a:lnSpc>
+                <a:spcPts val="1100"/>
+              </a:lnSpc>
+            </a:pPr>
+            <a:r>
+              <a:rPr lang="en-US" sz="900" dirty="0">
+                <a:solidFill>
+                  <a:srgbClr val="C9D1D9"/>
+                </a:solidFill>
+                <a:latin typeface="Segoe UI"/>
+              </a:rPr>
+              <a:t>Visual workspace for architecture visualization and complex refactoring</a:t>
+            </a:r>
+          </a:p>
+        </p:txBody>
+      </p:sp>
+      <p:sp>
+        <p:nvSpPr>
+          <p:cNvPr id="19" name="FeatureLabel2"/>
+          <p:cNvSpPr/>
+          <p:nvPr/>
+        </p:nvSpPr>
+        <p:spPr>
+          <a:xfrm>
+            <a:off x="457200" y="2654300"/>
+            <a:ext cx="1835404" cy="1206500"/>
+          </a:xfrm>
+          <a:prstGeom prst="roundRect">
+            <a:avLst>
+              <a:gd name="adj" fmla="val 5000"/>
+            </a:avLst>
+          </a:prstGeom>
+          <a:ln w="12700">
+            <a:solidFill>
+              <a:srgbClr val="30363D"/>
+            </a:solidFill>
+          </a:ln>
+        </p:spPr>
+        <p:txBody>
+          <a:bodyPr wrap="square" lIns="54000" tIns="36000" rIns="54000" bIns="36000" anchor="ctr"/>
+          <a:lstStyle/>
+          <a:p>
+            <a:pPr algn="ctr">
+              <a:lnSpc>
+                <a:spcPts val="1200"/>
+              </a:lnSpc>
+            </a:pPr>
+            <a:r>
+              <a:rPr lang="en-US" sz="1100" b="1" dirty="0">
+                <a:solidFill>
+                  <a:srgbClr val="58A6FF"/>
+                </a:solidFill>
+                <a:latin typeface="Segoe UI Semibold"/>
+              </a:rPr>
+              <a:t>Agentic Automation</a:t>
+            </a:r>
+          </a:p>
+          <a:p>
+            <a:pPr algn="ctr">
+              <a:lnSpc>
+                <a:spcPts val="1000"/>
+              </a:lnSpc>
+            </a:pPr>
+            <a:r>
+              <a:rPr lang="en-US" sz="800" i="1" dirty="0">
+                <a:solidFill>
+                  <a:srgbClr val="8B949E"/>
+                </a:solidFill>
+                <a:latin typeface="Segoe UI"/>
+              </a:rPr>
+              <a:t>CLI &amp; SDK</a:t>
+            </a:r>
+          </a:p>
+        </p:txBody>
+      </p:sp>
+      <p:sp>
+        <p:nvSpPr>
+          <p:cNvPr id="20" name="Cell_2_1"/>
+          <p:cNvSpPr/>
+          <p:nvPr/>
+        </p:nvSpPr>
+        <p:spPr>
+          <a:xfrm>
+            <a:off x="2343404" y="2654300"/>
+            <a:ext cx="3088132" cy="1206500"/>
+          </a:xfrm>
+          <a:prstGeom prst="roundRect">
+            <a:avLst>
+              <a:gd name="adj" fmla="val 5000"/>
+            </a:avLst>
+          </a:prstGeom>
+          <a:ln w="12700">
+            <a:solidFill>
+              <a:srgbClr val="30363D"/>
+            </a:solidFill>
+          </a:ln>
+        </p:spPr>
+        <p:txBody>
+          <a:bodyPr wrap="square" lIns="54000" tIns="36000" rIns="54000" bIns="36000" anchor="ctr"/>
+          <a:lstStyle/>
+          <a:p>
+            <a:pPr algn="l">
+              <a:lnSpc>
+                <a:spcPts val="1200"/>
+              </a:lnSpc>
+              <a:spcAft>
+                <a:spcPts val="200"/>
+              </a:spcAft>
+            </a:pPr>
+            <a:r>
+              <a:rPr lang="en-US" sz="1000" b="1" dirty="0">
+                <a:solidFill>
+                  <a:srgbClr val="3FB950"/>
+                </a:solidFill>
+                <a:latin typeface="Segoe UI Semibold"/>
+              </a:rPr>
+              <a:t>Command Suggestion</a:t>
+            </a:r>
+          </a:p>
+          <a:p>
+            <a:pPr algn="l">
+              <a:lnSpc>
+                <a:spcPts val="1100"/>
+              </a:lnSpc>
+            </a:pPr>
+            <a:r>
+              <a:rPr lang="en-US" sz="900" dirty="0">
+                <a:solidFill>
+                  <a:srgbClr val="C9D1D9"/>
+                </a:solidFill>
+                <a:latin typeface="Segoe UI"/>
+              </a:rPr>
+              <a:t>Basic gh copilot suggest in terminal</a:t>
+            </a:r>
+          </a:p>
+        </p:txBody>
+      </p:sp>
+      <p:sp>
+        <p:nvSpPr>
+          <p:cNvPr id="21" name="Cell_2_2"/>
+          <p:cNvSpPr/>
+          <p:nvPr/>
+        </p:nvSpPr>
+        <p:spPr>
+          <a:xfrm>
+            <a:off x="5482336" y="2654300"/>
+            <a:ext cx="3088132" cy="1206500"/>
+          </a:xfrm>
+          <a:prstGeom prst="roundRect">
+            <a:avLst>
+              <a:gd name="adj" fmla="val 5000"/>
+            </a:avLst>
+          </a:prstGeom>
+          <a:ln w="12700">
+            <a:solidFill>
+              <a:srgbClr val="30363D"/>
+            </a:solidFill>
+          </a:ln>
+        </p:spPr>
+        <p:txBody>
+          <a:bodyPr wrap="square" lIns="54000" tIns="36000" rIns="54000" bIns="36000" anchor="ctr"/>
+          <a:lstStyle/>
+          <a:p>
+            <a:pPr algn="l">
+              <a:lnSpc>
+                <a:spcPts val="1200"/>
+              </a:lnSpc>
+              <a:spcAft>
+                <a:spcPts val="200"/>
+              </a:spcAft>
+            </a:pPr>
+            <a:r>
+              <a:rPr lang="en-US" sz="1000" b="1" dirty="0">
+                <a:solidFill>
+                  <a:srgbClr val="58A6FF"/>
+                </a:solidFill>
+                <a:latin typeface="Segoe UI Semibold"/>
+              </a:rPr>
+              <a:t>Interactive CLI Chat</a:t>
+            </a:r>
+          </a:p>
+          <a:p>
+            <a:pPr algn="l">
+              <a:lnSpc>
+                <a:spcPts val="1100"/>
+              </a:lnSpc>
+            </a:pPr>
+            <a:r>
+              <a:rPr lang="en-US" sz="900" dirty="0">
+                <a:solidFill>
+                  <a:srgbClr val="C9D1D9"/>
+                </a:solidFill>
+                <a:latin typeface="Segoe UI"/>
+              </a:rPr>
+              <a:t>Debugging terminal errors and shell scripts</a:t>
+            </a:r>
+          </a:p>
+        </p:txBody>
+      </p:sp>
+      <p:sp>
+        <p:nvSpPr>
+          <p:cNvPr id="22" name="Cell_2_3"/>
+          <p:cNvSpPr/>
+          <p:nvPr/>
+        </p:nvSpPr>
+        <p:spPr>
+          <a:xfrm>
+            <a:off x="8621268" y="2654300"/>
+            <a:ext cx="3088132" cy="1206500"/>
+          </a:xfrm>
+          <a:prstGeom prst="roundRect">
+            <a:avLst>
+              <a:gd name="adj" fmla="val 5000"/>
+            </a:avLst>
+          </a:prstGeom>
+          <a:ln w="12700">
+            <a:solidFill>
+              <a:srgbClr val="30363D"/>
+            </a:solidFill>
+          </a:ln>
+        </p:spPr>
+        <p:txBody>
+          <a:bodyPr wrap="square" lIns="54000" tIns="36000" rIns="54000" bIns="36000" anchor="ctr"/>
+          <a:lstStyle/>
+          <a:p>
+            <a:pPr algn="l">
+              <a:lnSpc>
+                <a:spcPts val="1200"/>
+              </a:lnSpc>
+              <a:spcAft>
+                <a:spcPts val="200"/>
+              </a:spcAft>
+            </a:pPr>
+            <a:r>
+              <a:rPr lang="en-US" sz="1000" b="1" dirty="0">
+                <a:solidFill>
+                  <a:srgbClr val="BC8CFF"/>
+                </a:solidFill>
+                <a:latin typeface="Segoe UI Semibold"/>
+              </a:rPr>
+              <a:t>CLI Autopilot Mode</a:t>
+            </a:r>
+          </a:p>
+          <a:p>
+            <a:pPr algn="l">
+              <a:lnSpc>
+                <a:spcPts val="1100"/>
+              </a:lnSpc>
+            </a:pPr>
+            <a:r>
+              <a:rPr lang="en-US" sz="900" dirty="0">
+                <a:solidFill>
+                  <a:srgbClr val="C9D1D9"/>
+                </a:solidFill>
+                <a:latin typeface="Segoe UI"/>
+              </a:rPr>
+              <a:t>Autonomous plan-act-review loops for complex file operations</a:t>
+            </a:r>
+          </a:p>
+        </p:txBody>
+      </p:sp>
+      <p:sp>
+        <p:nvSpPr>
+          <p:cNvPr id="23" name="FeatureLabel3"/>
+          <p:cNvSpPr/>
+          <p:nvPr/>
+        </p:nvSpPr>
+        <p:spPr>
+          <a:xfrm>
+            <a:off x="457200" y="4000500"/>
+            <a:ext cx="1835404" cy="1206500"/>
+          </a:xfrm>
+          <a:prstGeom prst="roundRect">
+            <a:avLst>
+              <a:gd name="adj" fmla="val 5000"/>
+            </a:avLst>
+          </a:prstGeom>
+          <a:ln w="12700">
+            <a:solidFill>
+              <a:srgbClr val="30363D"/>
+            </a:solidFill>
+          </a:ln>
+        </p:spPr>
+        <p:txBody>
+          <a:bodyPr wrap="square" lIns="54000" tIns="36000" rIns="54000" bIns="36000" anchor="ctr"/>
+          <a:lstStyle/>
+          <a:p>
+            <a:pPr algn="ctr">
+              <a:lnSpc>
+                <a:spcPts val="1200"/>
+              </a:lnSpc>
+            </a:pPr>
+            <a:r>
+              <a:rPr lang="en-US" sz="1100" b="1" dirty="0">
+                <a:solidFill>
+                  <a:srgbClr val="D29922"/>
+                </a:solidFill>
+                <a:latin typeface="Segoe UI Semibold"/>
+              </a:rPr>
+              <a:t>Enterprise Knowledge</a:t>
+            </a:r>
+          </a:p>
+          <a:p>
+            <a:pPr algn="ctr">
+              <a:lnSpc>
+                <a:spcPts val="1000"/>
+              </a:lnSpc>
+            </a:pPr>
+            <a:r>
+              <a:rPr lang="en-US" sz="800" i="1" dirty="0">
+                <a:solidFill>
+                  <a:srgbClr val="8B949E"/>
+                </a:solidFill>
+                <a:latin typeface="Segoe UI"/>
+              </a:rPr>
+              <a:t>Governance</a:t>
+            </a:r>
+          </a:p>
+        </p:txBody>
+      </p:sp>
+      <p:sp>
+        <p:nvSpPr>
+          <p:cNvPr id="24" name="Cell_3_1"/>
+          <p:cNvSpPr/>
+          <p:nvPr/>
+        </p:nvSpPr>
+        <p:spPr>
+          <a:xfrm>
+            <a:off x="2343404" y="4000500"/>
+            <a:ext cx="3088132" cy="1206500"/>
+          </a:xfrm>
+          <a:prstGeom prst="roundRect">
+            <a:avLst>
+              <a:gd name="adj" fmla="val 5000"/>
+            </a:avLst>
+          </a:prstGeom>
+          <a:ln w="12700">
+            <a:solidFill>
+              <a:srgbClr val="30363D"/>
+            </a:solidFill>
+          </a:ln>
+        </p:spPr>
+        <p:txBody>
+          <a:bodyPr wrap="square" lIns="54000" tIns="36000" rIns="54000" bIns="36000" anchor="ctr"/>
+          <a:lstStyle/>
+          <a:p>
+            <a:pPr algn="l">
+              <a:lnSpc>
+                <a:spcPts val="1200"/>
+              </a:lnSpc>
+              <a:spcAft>
+                <a:spcPts val="200"/>
+              </a:spcAft>
+            </a:pPr>
+            <a:r>
+              <a:rPr lang="en-US" sz="1000" b="1" dirty="0">
+                <a:solidFill>
+                  <a:srgbClr val="3FB950"/>
+                </a:solidFill>
+                <a:latin typeface="Segoe UI Semibold"/>
+              </a:rPr>
+              <a:t>Content Exclusion</a:t>
+            </a:r>
+          </a:p>
+          <a:p>
+            <a:pPr algn="l">
+              <a:lnSpc>
+                <a:spcPts val="1100"/>
+              </a:lnSpc>
+            </a:pPr>
+            <a:r>
+              <a:rPr lang="en-US" sz="900" dirty="0">
+                <a:solidFill>
+                  <a:srgbClr val="C9D1D9"/>
+                </a:solidFill>
+                <a:latin typeface="Segoe UI"/>
+              </a:rPr>
+              <a:t>Basic safety controls on file visibility</a:t>
+            </a:r>
+          </a:p>
+        </p:txBody>
+      </p:sp>
+      <p:sp>
+        <p:nvSpPr>
+          <p:cNvPr id="25" name="Cell_3_2"/>
+          <p:cNvSpPr/>
+          <p:nvPr/>
+        </p:nvSpPr>
+        <p:spPr>
+          <a:xfrm>
+            <a:off x="5482336" y="4000500"/>
+            <a:ext cx="3088132" cy="1206500"/>
+          </a:xfrm>
+          <a:prstGeom prst="roundRect">
+            <a:avLst>
+              <a:gd name="adj" fmla="val 5000"/>
+            </a:avLst>
+          </a:prstGeom>
+          <a:ln w="12700">
+            <a:solidFill>
+              <a:srgbClr val="30363D"/>
+            </a:solidFill>
+          </a:ln>
+        </p:spPr>
+        <p:txBody>
+          <a:bodyPr wrap="square" lIns="54000" tIns="36000" rIns="54000" bIns="36000" anchor="ctr"/>
+          <a:lstStyle/>
+          <a:p>
+            <a:pPr algn="l">
+              <a:lnSpc>
+                <a:spcPts val="1200"/>
+              </a:lnSpc>
+              <a:spcAft>
+                <a:spcPts val="200"/>
+              </a:spcAft>
+            </a:pPr>
+            <a:r>
+              <a:rPr lang="en-US" sz="1000" b="1" dirty="0">
+                <a:solidFill>
+                  <a:srgbClr val="58A6FF"/>
+                </a:solidFill>
+                <a:latin typeface="Segoe UI Semibold"/>
+              </a:rPr>
+              <a:t>Knowledge Bases</a:t>
+            </a:r>
+          </a:p>
+          <a:p>
+            <a:pPr algn="l">
+              <a:lnSpc>
+                <a:spcPts val="1100"/>
+              </a:lnSpc>
+            </a:pPr>
+            <a:r>
+              <a:rPr lang="en-US" sz="900" dirty="0">
+                <a:solidFill>
+                  <a:srgbClr val="C9D1D9"/>
+                </a:solidFill>
+                <a:latin typeface="Segoe UI"/>
+              </a:rPr>
+              <a:t>Indexing internal docs/Wikis for contextual answers</a:t>
+            </a:r>
+          </a:p>
+        </p:txBody>
+      </p:sp>
+      <p:sp>
+        <p:nvSpPr>
+          <p:cNvPr id="26" name="Cell_3_3"/>
+          <p:cNvSpPr/>
+          <p:nvPr/>
+        </p:nvSpPr>
+        <p:spPr>
+          <a:xfrm>
+            <a:off x="8621268" y="4000500"/>
+            <a:ext cx="3088132" cy="1206500"/>
+          </a:xfrm>
+          <a:prstGeom prst="roundRect">
+            <a:avLst>
+              <a:gd name="adj" fmla="val 5000"/>
+            </a:avLst>
+          </a:prstGeom>
+          <a:ln w="12700">
+            <a:solidFill>
+              <a:srgbClr val="30363D"/>
+            </a:solidFill>
+          </a:ln>
+        </p:spPr>
+        <p:txBody>
+          <a:bodyPr wrap="square" lIns="54000" tIns="36000" rIns="54000" bIns="36000" anchor="ctr"/>
+          <a:lstStyle/>
+          <a:p>
+            <a:pPr algn="l">
+              <a:lnSpc>
+                <a:spcPts val="1200"/>
+              </a:lnSpc>
+              <a:spcAft>
+                <a:spcPts val="200"/>
+              </a:spcAft>
+            </a:pPr>
+            <a:r>
+              <a:rPr lang="en-US" sz="1000" b="1" dirty="0">
+                <a:solidFill>
+                  <a:srgbClr val="BC8CFF"/>
+                </a:solidFill>
+                <a:latin typeface="Segoe UI Semibold"/>
+              </a:rPr>
+              <a:t>AI Code Review Agent</a:t>
+            </a:r>
+          </a:p>
+          <a:p>
+            <a:pPr algn="l">
+              <a:lnSpc>
+                <a:spcPts val="1100"/>
+              </a:lnSpc>
+            </a:pPr>
+            <a:r>
+              <a:rPr lang="en-US" sz="900" dirty="0">
+                <a:solidFill>
+                  <a:srgbClr val="C9D1D9"/>
+                </a:solidFill>
+                <a:latin typeface="Segoe UI"/>
+              </a:rPr>
+              <a:t>Autonomous security and standards auditing on PRs</a:t>
+            </a:r>
+          </a:p>
+        </p:txBody>
+      </p:sp>
+      <p:sp>
+        <p:nvSpPr>
+          <p:cNvPr id="27" name="FeatureLabel4"/>
+          <p:cNvSpPr/>
+          <p:nvPr/>
+        </p:nvSpPr>
+        <p:spPr>
+          <a:xfrm>
+            <a:off x="457200" y="5346700"/>
+            <a:ext cx="1835404" cy="1206500"/>
+          </a:xfrm>
+          <a:prstGeom prst="roundRect">
+            <a:avLst>
+              <a:gd name="adj" fmla="val 5000"/>
+            </a:avLst>
+          </a:prstGeom>
+          <a:ln w="12700">
+            <a:solidFill>
+              <a:srgbClr val="30363D"/>
+            </a:solidFill>
+          </a:ln>
+        </p:spPr>
+        <p:txBody>
+          <a:bodyPr wrap="square" lIns="54000" tIns="36000" rIns="54000" bIns="36000" anchor="ctr"/>
+          <a:lstStyle/>
+          <a:p>
+            <a:pPr algn="ctr">
+              <a:lnSpc>
+                <a:spcPts val="1200"/>
+              </a:lnSpc>
+            </a:pPr>
+            <a:r>
+              <a:rPr lang="en-US" sz="1100" b="1" dirty="0">
+                <a:solidFill>
+                  <a:srgbClr val="F78166"/>
+                </a:solidFill>
+                <a:latin typeface="Segoe UI Semibold"/>
+              </a:rPr>
+              <a:t>Extensions &amp; Modernization</a:t>
+            </a:r>
+          </a:p>
+          <a:p>
+            <a:pPr algn="ctr">
+              <a:lnSpc>
+                <a:spcPts val="1000"/>
+              </a:lnSpc>
+            </a:pPr>
+            <a:r>
+              <a:rPr lang="en-US" sz="800" i="1" dirty="0">
+                <a:solidFill>
+                  <a:srgbClr val="8B949E"/>
+                </a:solidFill>
+                <a:latin typeface="Segoe UI"/>
+              </a:rPr>
+              <a:t>Ecosystem</a:t>
+            </a:r>
+          </a:p>
+        </p:txBody>
+      </p:sp>
+      <p:sp>
+        <p:nvSpPr>
+          <p:cNvPr id="28" name="Cell_4_1"/>
+          <p:cNvSpPr/>
+          <p:nvPr/>
+        </p:nvSpPr>
+        <p:spPr>
+          <a:xfrm>
+            <a:off x="2343404" y="5346700"/>
+            <a:ext cx="3088132" cy="1206500"/>
+          </a:xfrm>
+          <a:prstGeom prst="roundRect">
+            <a:avLst>
+              <a:gd name="adj" fmla="val 5000"/>
+            </a:avLst>
+          </a:prstGeom>
+          <a:ln w="12700">
+            <a:solidFill>
+              <a:srgbClr val="30363D"/>
+            </a:solidFill>
+          </a:ln>
+        </p:spPr>
+        <p:txBody>
+          <a:bodyPr wrap="square" lIns="54000" tIns="36000" rIns="54000" bIns="36000" anchor="ctr"/>
+          <a:lstStyle/>
+          <a:p>
+            <a:pPr algn="l">
+              <a:lnSpc>
+                <a:spcPts val="1200"/>
+              </a:lnSpc>
+              <a:spcAft>
+                <a:spcPts val="200"/>
+              </a:spcAft>
+            </a:pPr>
+            <a:r>
+              <a:rPr lang="en-US" sz="1000" b="1" dirty="0">
+                <a:solidFill>
+                  <a:srgbClr val="3FB950"/>
+                </a:solidFill>
+                <a:latin typeface="Segoe UI Semibold"/>
+              </a:rPr>
+              <a:t>Slash Commands</a:t>
+            </a:r>
+          </a:p>
+          <a:p>
+            <a:pPr algn="l">
+              <a:lnSpc>
+                <a:spcPts val="1100"/>
+              </a:lnSpc>
+            </a:pPr>
+            <a:r>
+              <a:rPr lang="en-US" sz="900" dirty="0">
+                <a:solidFill>
+                  <a:srgbClr val="C9D1D9"/>
+                </a:solidFill>
+                <a:latin typeface="Segoe UI"/>
+              </a:rPr>
+              <a:t>Basic code refactoring (/fix)</a:t>
+            </a:r>
+          </a:p>
+        </p:txBody>
+      </p:sp>
+      <p:sp>
+        <p:nvSpPr>
+          <p:cNvPr id="29" name="Cell_4_2"/>
+          <p:cNvSpPr/>
+          <p:nvPr/>
+        </p:nvSpPr>
+        <p:spPr>
+          <a:xfrm>
+            <a:off x="5482336" y="5346700"/>
+            <a:ext cx="3088132" cy="1206500"/>
+          </a:xfrm>
+          <a:prstGeom prst="roundRect">
+            <a:avLst>
+              <a:gd name="adj" fmla="val 5000"/>
+            </a:avLst>
+          </a:prstGeom>
+          <a:ln w="12700">
+            <a:solidFill>
+              <a:srgbClr val="30363D"/>
+            </a:solidFill>
+          </a:ln>
+        </p:spPr>
+        <p:txBody>
+          <a:bodyPr wrap="square" lIns="54000" tIns="36000" rIns="54000" bIns="36000" anchor="ctr"/>
+          <a:lstStyle/>
+          <a:p>
+            <a:pPr algn="l">
+              <a:lnSpc>
+                <a:spcPts val="1200"/>
+              </a:lnSpc>
+              <a:spcAft>
+                <a:spcPts val="200"/>
+              </a:spcAft>
+            </a:pPr>
+            <a:r>
+              <a:rPr lang="en-US" sz="1000" b="1" dirty="0">
+                <a:solidFill>
+                  <a:srgbClr val="58A6FF"/>
+                </a:solidFill>
+                <a:latin typeface="Segoe UI Semibold"/>
+              </a:rPr>
+              <a:t>1st Party Extensions</a:t>
+            </a:r>
+          </a:p>
+          <a:p>
+            <a:pPr algn="l">
+              <a:lnSpc>
+                <a:spcPts val="1100"/>
+              </a:lnSpc>
+            </a:pPr>
+            <a:r>
+              <a:rPr lang="en-US" sz="900" dirty="0">
+                <a:solidFill>
+                  <a:srgbClr val="C9D1D9"/>
+                </a:solidFill>
+                <a:latin typeface="Segoe UI"/>
+              </a:rPr>
+              <a:t>Connecting to Azure Database, Teams, and more</a:t>
+            </a:r>
+          </a:p>
+        </p:txBody>
+      </p:sp>
+      <p:sp>
+        <p:nvSpPr>
+          <p:cNvPr id="30" name="Cell_4_3"/>
+          <p:cNvSpPr/>
+          <p:nvPr/>
+        </p:nvSpPr>
+        <p:spPr>
+          <a:xfrm>
+            <a:off x="8621268" y="5346700"/>
+            <a:ext cx="3088132" cy="1206500"/>
+          </a:xfrm>
+          <a:prstGeom prst="roundRect">
+            <a:avLst>
+              <a:gd name="adj" fmla="val 5000"/>
+            </a:avLst>
+          </a:prstGeom>
+          <a:ln w="12700">
+            <a:solidFill>
+              <a:srgbClr val="30363D"/>
+            </a:solidFill>
+          </a:ln>
+        </p:spPr>
+        <p:txBody>
+          <a:bodyPr wrap="square" lIns="54000" tIns="36000" rIns="54000" bIns="36000" anchor="ctr"/>
+          <a:lstStyle/>
+          <a:p>
+            <a:pPr algn="l">
+              <a:lnSpc>
+                <a:spcPts val="1100"/>
+              </a:lnSpc>
+              <a:spcAft>
+                <a:spcPts val="100"/>
+              </a:spcAft>
+            </a:pPr>
+            <a:r>
+              <a:rPr lang="en-US" sz="1000" b="1" dirty="0">
+                <a:solidFill>
+                  <a:srgbClr val="BC8CFF"/>
+                </a:solidFill>
+                <a:latin typeface="Segoe UI Semibold"/>
+              </a:rPr>
+              <a:t>Modernization Agent</a:t>
+            </a:r>
+          </a:p>
+          <a:p>
+            <a:pPr algn="l">
+              <a:lnSpc>
+                <a:spcPts val="1000"/>
+              </a:lnSpc>
+              <a:spcAft>
+                <a:spcPts val="100"/>
+              </a:spcAft>
+            </a:pPr>
+            <a:r>
+              <a:rPr lang="en-US" sz="800" dirty="0">
+                <a:solidFill>
+                  <a:srgbClr val="C9D1D9"/>
+                </a:solidFill>
+                <a:latin typeface="Segoe UI"/>
+              </a:rPr>
+              <a:t>Assess → Plan → Execute: .NET/Java to Azure migration</a:t>
+            </a:r>
+          </a:p>
+          <a:p>
+            <a:pPr algn="l">
+              <a:lnSpc>
+                <a:spcPts val="1000"/>
+              </a:lnSpc>
+            </a:pPr>
+            <a:r>
+              <a:rPr lang="en-US" sz="900" b="1" i="1" dirty="0">
+                <a:solidFill>
+                  <a:srgbClr val="D2A8FF"/>
+                </a:solidFill>
+                <a:latin typeface="Segoe UI Semibold"/>
+              </a:rPr>
+              <a:t>+ Vibe Coding (Agent Mode)</a:t>
+            </a:r>
+          </a:p>
+        </p:txBody>
+      </p:sp>
+      <p:sp>
+        <p:nvSpPr>
+          <p:cNvPr id="32" name="ArrowLabel0"/>
+          <p:cNvSpPr/>
+          <p:nvPr/>
+        </p:nvSpPr>
+        <p:spPr>
+          <a:xfrm>
+            <a:off x="2343404" y="6667500"/>
+            <a:ext cx="3088132" cy="177800"/>
+          </a:xfrm>
+          <a:prstGeom prst="rect">
+            <a:avLst/>
+          </a:prstGeom>
+          <a:noFill/>
+          <a:ln>
+            <a:noFill/>
+          </a:ln>
+        </p:spPr>
+        <p:txBody>
+          <a:bodyPr wrap="square" lIns="54000" tIns="36000" rIns="54000" bIns="36000" anchor="ctr"/>
+          <a:lstStyle/>
+          <a:p>
+            <a:pPr algn="l"/>
+            <a:r>
+              <a:rPr lang="en-US" sz="1000" dirty="0">
+                <a:solidFill>
+                  <a:srgbClr val="3FB950"/>
+                </a:solidFill>
+                <a:latin typeface="Segoe UI"/>
+              </a:rPr>
+              <a:t>◀ Reactive • Single-task</a:t>
+            </a:r>
+          </a:p>
+        </p:txBody>
+      </p:sp>
+      <p:sp>
+        <p:nvSpPr>
+          <p:cNvPr id="33" name="ArrowLabel1"/>
+          <p:cNvSpPr/>
+          <p:nvPr/>
+        </p:nvSpPr>
+        <p:spPr>
+          <a:xfrm>
+            <a:off x="5482336" y="6667500"/>
+            <a:ext cx="3088132" cy="177800"/>
+          </a:xfrm>
+          <a:prstGeom prst="rect">
+            <a:avLst/>
+          </a:prstGeom>
+          <a:noFill/>
+          <a:ln>
+            <a:noFill/>
+          </a:ln>
+        </p:spPr>
+        <p:txBody>
+          <a:bodyPr wrap="square" lIns="54000" tIns="36000" rIns="54000" bIns="36000" anchor="ctr"/>
+          <a:lstStyle/>
+          <a:p>
+            <a:pPr algn="ctr"/>
+            <a:r>
+              <a:rPr lang="en-US" sz="1000" dirty="0">
+                <a:solidFill>
+                  <a:srgbClr val="58A6FF"/>
+                </a:solidFill>
+                <a:latin typeface="Segoe UI"/>
+              </a:rPr>
+              <a:t>Multi-file • Context-aware</a:t>
+            </a:r>
+          </a:p>
+        </p:txBody>
+      </p:sp>
+      <p:sp>
+        <p:nvSpPr>
+          <p:cNvPr id="34" name="ArrowLabel2"/>
+          <p:cNvSpPr/>
+          <p:nvPr/>
+        </p:nvSpPr>
+        <p:spPr>
+          <a:xfrm>
+            <a:off x="8621268" y="6667500"/>
+            <a:ext cx="3088132" cy="177800"/>
+          </a:xfrm>
+          <a:prstGeom prst="rect">
+            <a:avLst/>
+          </a:prstGeom>
+          <a:noFill/>
+          <a:ln>
+            <a:noFill/>
+          </a:ln>
+        </p:spPr>
+        <p:txBody>
+          <a:bodyPr wrap="square" lIns="54000" tIns="36000" rIns="54000" bIns="36000" anchor="ctr"/>
+          <a:lstStyle/>
+          <a:p>
+            <a:pPr algn="r"/>
+            <a:r>
+              <a:rPr lang="en-US" sz="1000" dirty="0">
+                <a:solidFill>
+                  <a:srgbClr val="BC8CFF"/>
+                </a:solidFill>
+                <a:latin typeface="Segoe UI"/>
+              </a:rPr>
+              <a:t>Autonomous • Goal-oriented ▶</a:t>
+            </a:r>
+          </a:p>
+        </p:txBody>
+      </p:sp>
+      <p:sp>
+        <p:nvSpPr>
+          <p:cNvPr id="40" name="4SBadge"/>
+          <p:cNvSpPr/>
+          <p:nvPr/>
+        </p:nvSpPr>
+        <p:spPr>
+          <a:xfrm>
+            <a:off x="457200" y="6604000"/>
+            <a:ext cx="1841500" cy="228600"/>
+          </a:xfrm>
+          <a:prstGeom prst="roundRect">
+            <a:avLst>
+              <a:gd name="adj" fmla="val 16667"/>
+            </a:avLst>
+          </a:prstGeom>
+          <a:solidFill>
+            <a:srgbClr val="2A1F0D"/>
+          </a:solidFill>
+          <a:ln w="6350">
+            <a:solidFill>
+              <a:srgbClr val="D29922"/>
+            </a:solidFill>
+          </a:ln>
+        </p:spPr>
+        <p:txBody>
+          <a:bodyPr wrap="square" lIns="36000" tIns="18000" rIns="36000" bIns="18000" anchor="ctr"/>
+          <a:lstStyle/>
+          <a:p>
+            <a:pPr algn="ctr"/>
+            <a:r>
+              <a:rPr lang="en-US" sz="800" b="1" dirty="0">
+                <a:solidFill>
+                  <a:srgbClr val="D29922"/>
+                </a:solidFill>
+                <a:latin typeface="Segoe UI Semibold"/>
+              </a:rPr>
+              <a:t>⚡ 4S Prompting Method</a:t>
+            </a:r>
+          </a:p>
+        </p:txBody>
+      </p:sp>
+      <p:sp>
+        <p:nvSpPr>
+          <p:cNvPr id="50" name="AccentBar"/>
           <p:cNvSpPr/>
           <p:nvPr/>
         </p:nvSpPr>
         <p:spPr>
           <a:xfrm>
             <a:off x="0" y="0"/>
-            <a:ext cx="12188952" cy="45720"/>
-          </a:xfrm>
-          <a:prstGeom prst="rectangle">
+            <a:ext cx="12192000" cy="38100"/>
+          </a:xfrm>
+          <a:prstGeom prst="rect">
             <a:avLst/>
           </a:prstGeom>
           <a:solidFill>
-            <a:srgbClr val="2F81F7"/>
+            <a:srgbClr val="58A6FF"/>
           </a:solidFill>
-          <a:ln/>
-        </p:spPr>
-      </p:sp>
-      <p:sp>
-        <p:nvSpPr>
-          <p:cNvPr id="3" name="Text 1"/>
-          <p:cNvSpPr/>
-          <p:nvPr/>
-        </p:nvSpPr>
-        <p:spPr>
-          <a:xfrm>
-            <a:off x="457200" y="137160"/>
-            <a:ext cx="7772400" cy="457200"/>
-          </a:xfrm>
-          <a:prstGeom prst="rect">
-            <a:avLst/>
-          </a:prstGeom>
-          <a:noFill/>
-          <a:ln/>
-        </p:spPr>
-        <p:txBody>
-          <a:bodyPr wrap="square" lIns="0" tIns="0" rIns="0" bIns="0" rtlCol="0" anchor="ctr"/>
-          <a:lstStyle/>
-          <a:p>
-            <a:pPr indent="0" marL="0">
-              <a:buNone/>
-            </a:pPr>
-            <a:r>
-              <a:rPr lang="en-US" sz="2200" b="1" dirty="0">
-                <a:solidFill>
-                  <a:srgbClr val="FFFFFF"/>
-                </a:solidFill>
-                <a:latin typeface="Calibri" pitchFamily="34" charset="0"/>
-                <a:ea typeface="Calibri" pitchFamily="34" charset="-122"/>
-                <a:cs typeface="Calibri" pitchFamily="34" charset="-120"/>
-              </a:rPr>
-              <a:t>GitHub Copilot Proficiency Matrix</a:t>
-            </a:r>
-            <a:endParaRPr lang="en-US" sz="2200" dirty="0"/>
-          </a:p>
-        </p:txBody>
-      </p:sp>
-      <p:sp>
-        <p:nvSpPr>
-          <p:cNvPr id="4" name="Text 2"/>
-          <p:cNvSpPr/>
-          <p:nvPr/>
-        </p:nvSpPr>
-        <p:spPr>
-          <a:xfrm>
-            <a:off x="457200" y="475488"/>
-            <a:ext cx="7772400" cy="274320"/>
-          </a:xfrm>
-          <a:prstGeom prst="rect">
-            <a:avLst/>
-          </a:prstGeom>
-          <a:noFill/>
-          <a:ln/>
-        </p:spPr>
-        <p:txBody>
-          <a:bodyPr wrap="square" lIns="0" tIns="0" rIns="0" bIns="0" rtlCol="0" anchor="ctr"/>
-          <a:lstStyle/>
-          <a:p>
-            <a:pPr indent="0" marL="0">
-              <a:buNone/>
-            </a:pPr>
-            <a:r>
-              <a:rPr lang="en-US" sz="1200" dirty="0">
-                <a:solidFill>
-                  <a:srgbClr val="8B949E"/>
-                </a:solidFill>
-                <a:latin typeface="Calibri" pitchFamily="34" charset="0"/>
-                <a:ea typeface="Calibri" pitchFamily="34" charset="-122"/>
-                <a:cs typeface="Calibri" pitchFamily="34" charset="-120"/>
-              </a:rPr>
-              <a:t>Feature Threads × Advancement Zones</a:t>
-            </a:r>
-            <a:endParaRPr lang="en-US" sz="1200" dirty="0"/>
-          </a:p>
-        </p:txBody>
-      </p:sp>
-      <p:sp>
-        <p:nvSpPr>
-          <p:cNvPr id="5" name="Shape 3"/>
-          <p:cNvSpPr/>
-          <p:nvPr/>
-        </p:nvSpPr>
-        <p:spPr>
-          <a:xfrm>
-            <a:off x="8412480" y="137160"/>
-            <a:ext cx="3474720" cy="274320"/>
-          </a:xfrm>
-          <a:prstGeom prst="rectangle">
-            <a:avLst/>
-          </a:prstGeom>
-          <a:solidFill>
-            <a:srgbClr val="2F81F7">
-              <a:alpha val="25000"/>
-            </a:srgbClr>
-          </a:solidFill>
-          <a:ln/>
-        </p:spPr>
-      </p:sp>
-      <p:sp>
-        <p:nvSpPr>
-          <p:cNvPr id="6" name="Text 4"/>
-          <p:cNvSpPr/>
-          <p:nvPr/>
-        </p:nvSpPr>
-        <p:spPr>
-          <a:xfrm>
-            <a:off x="8412480" y="137160"/>
-            <a:ext cx="3474720" cy="274320"/>
-          </a:xfrm>
-          <a:prstGeom prst="rect">
-            <a:avLst/>
-          </a:prstGeom>
-          <a:noFill/>
-          <a:ln/>
-        </p:spPr>
-        <p:txBody>
-          <a:bodyPr wrap="square" lIns="0" tIns="0" rIns="0" bIns="0" rtlCol="0" anchor="ctr"/>
-          <a:lstStyle/>
-          <a:p>
-            <a:pPr algn="ctr" indent="0" marL="0">
-              <a:buNone/>
-            </a:pPr>
-            <a:r>
-              <a:rPr lang="en-US" sz="900" dirty="0">
-                <a:solidFill>
-                  <a:srgbClr val="2F81F7"/>
-                </a:solidFill>
-                <a:latin typeface="Calibri" pitchFamily="34" charset="0"/>
-                <a:ea typeface="Calibri" pitchFamily="34" charset="-122"/>
-                <a:cs typeface="Calibri" pitchFamily="34" charset="-120"/>
-              </a:rPr>
-              <a:t>ORIENTATION MAP</a:t>
-            </a:r>
-            <a:endParaRPr lang="en-US" sz="900" dirty="0"/>
-          </a:p>
-        </p:txBody>
-      </p:sp>
-      <p:sp>
-        <p:nvSpPr>
-          <p:cNvPr id="7" name="Shape 5"/>
-          <p:cNvSpPr/>
-          <p:nvPr/>
-        </p:nvSpPr>
-        <p:spPr>
-          <a:xfrm>
-            <a:off x="457200" y="868680"/>
-            <a:ext cx="1645920" cy="502920"/>
-          </a:xfrm>
-          <a:prstGeom prst="rectangle">
-            <a:avLst/>
-          </a:prstGeom>
-          <a:solidFill>
-            <a:srgbClr val="161B22"/>
-          </a:solidFill>
-          <a:ln/>
-        </p:spPr>
-      </p:sp>
-      <p:sp>
-        <p:nvSpPr>
-          <p:cNvPr id="8" name="Text 6"/>
-          <p:cNvSpPr/>
-          <p:nvPr/>
-        </p:nvSpPr>
-        <p:spPr>
-          <a:xfrm>
-            <a:off x="457200" y="868680"/>
-            <a:ext cx="1645920" cy="502920"/>
-          </a:xfrm>
-          <a:prstGeom prst="rect">
-            <a:avLst/>
-          </a:prstGeom>
-          <a:noFill/>
-          <a:ln/>
-        </p:spPr>
-        <p:txBody>
-          <a:bodyPr wrap="square" lIns="0" tIns="0" rIns="0" bIns="0" rtlCol="0" anchor="ctr"/>
-          <a:lstStyle/>
-          <a:p>
-            <a:pPr algn="ctr" indent="0" marL="0">
-              <a:buNone/>
-            </a:pPr>
-            <a:r>
-              <a:rPr lang="en-US" sz="1000" b="1" dirty="0">
-                <a:solidFill>
-                  <a:srgbClr val="8B949E"/>
-                </a:solidFill>
-                <a:latin typeface="Calibri" pitchFamily="34" charset="0"/>
-                <a:ea typeface="Calibri" pitchFamily="34" charset="-122"/>
-                <a:cs typeface="Calibri" pitchFamily="34" charset="-120"/>
-              </a:rPr>
-              <a:t>FEATURE →</a:t>
-            </a:r>
-            <a:endParaRPr lang="en-US" sz="1000" dirty="0"/>
-          </a:p>
-        </p:txBody>
-      </p:sp>
-      <p:sp>
-        <p:nvSpPr>
-          <p:cNvPr id="9" name="Shape 7"/>
-          <p:cNvSpPr/>
-          <p:nvPr/>
-        </p:nvSpPr>
-        <p:spPr>
-          <a:xfrm>
-            <a:off x="2212848" y="868680"/>
-            <a:ext cx="3017520" cy="502920"/>
-          </a:xfrm>
-          <a:prstGeom prst="rectangle">
-            <a:avLst/>
-          </a:prstGeom>
-          <a:solidFill>
-            <a:srgbClr val="161B22"/>
-          </a:solidFill>
-          <a:ln/>
-        </p:spPr>
-      </p:sp>
-      <p:sp>
-        <p:nvSpPr>
-          <p:cNvPr id="10" name="Shape 8"/>
-          <p:cNvSpPr/>
-          <p:nvPr/>
-        </p:nvSpPr>
-        <p:spPr>
-          <a:xfrm>
-            <a:off x="2212848" y="868680"/>
-            <a:ext cx="3017520" cy="36576"/>
-          </a:xfrm>
-          <a:prstGeom prst="rectangle">
-            <a:avLst/>
-          </a:prstGeom>
-          <a:solidFill>
-            <a:srgbClr val="3FB950"/>
-          </a:solidFill>
-          <a:ln/>
-        </p:spPr>
-      </p:sp>
-      <p:sp>
-        <p:nvSpPr>
-          <p:cNvPr id="11" name="Text 9"/>
-          <p:cNvSpPr/>
-          <p:nvPr/>
-        </p:nvSpPr>
-        <p:spPr>
-          <a:xfrm>
-            <a:off x="2212848" y="923544"/>
-            <a:ext cx="3017520" cy="448056"/>
-          </a:xfrm>
-          <a:prstGeom prst="rect">
-            <a:avLst/>
-          </a:prstGeom>
-          <a:noFill/>
-          <a:ln/>
-        </p:spPr>
-        <p:txBody>
-          <a:bodyPr wrap="square" lIns="0" tIns="0" rIns="0" bIns="0" rtlCol="0" anchor="ctr"/>
-          <a:lstStyle/>
-          <a:p>
-            <a:pPr algn="ctr" indent="0" marL="0">
-              <a:buNone/>
-            </a:pPr>
-            <a:r>
-              <a:rPr lang="en-US" sz="1400" b="1" dirty="0">
-                <a:solidFill>
-                  <a:srgbClr val="3FB950"/>
-                </a:solidFill>
-                <a:latin typeface="Calibri" pitchFamily="34" charset="0"/>
-                <a:ea typeface="Calibri" pitchFamily="34" charset="-122"/>
-                <a:cs typeface="Calibri" pitchFamily="34" charset="-120"/>
-              </a:rPr>
-              <a:t>Zone 1: Foundational</a:t>
-            </a:r>
-            <a:endParaRPr lang="en-US" sz="1400" dirty="0"/>
-          </a:p>
-          <a:p>
-            <a:pPr algn="ctr" indent="0" marL="0">
-              <a:buNone/>
-            </a:pPr>
-            <a:r>
-              <a:rPr lang="en-US" sz="900" dirty="0">
-                <a:solidFill>
-                  <a:srgbClr val="8B949E"/>
-                </a:solidFill>
-                <a:latin typeface="Calibri" pitchFamily="34" charset="0"/>
-                <a:ea typeface="Calibri" pitchFamily="34" charset="-122"/>
-                <a:cs typeface="Calibri" pitchFamily="34" charset="-120"/>
-              </a:rPr>
-              <a:t>Assistive • IDE Editor Level</a:t>
-            </a:r>
-            <a:endParaRPr lang="en-US" sz="1400" dirty="0"/>
-          </a:p>
-        </p:txBody>
-      </p:sp>
-      <p:sp>
-        <p:nvSpPr>
-          <p:cNvPr id="12" name="Shape 10"/>
-          <p:cNvSpPr/>
-          <p:nvPr/>
-        </p:nvSpPr>
-        <p:spPr>
-          <a:xfrm>
-            <a:off x="5340096" y="868680"/>
-            <a:ext cx="3017520" cy="502920"/>
-          </a:xfrm>
-          <a:prstGeom prst="rectangle">
-            <a:avLst/>
-          </a:prstGeom>
-          <a:solidFill>
-            <a:srgbClr val="161B22"/>
-          </a:solidFill>
-          <a:ln/>
-        </p:spPr>
-      </p:sp>
-      <p:sp>
-        <p:nvSpPr>
-          <p:cNvPr id="13" name="Shape 11"/>
-          <p:cNvSpPr/>
-          <p:nvPr/>
-        </p:nvSpPr>
-        <p:spPr>
-          <a:xfrm>
-            <a:off x="5340096" y="868680"/>
-            <a:ext cx="3017520" cy="36576"/>
-          </a:xfrm>
-          <a:prstGeom prst="rectangle">
-            <a:avLst/>
-          </a:prstGeom>
-          <a:solidFill>
-            <a:srgbClr val="D29922"/>
-          </a:solidFill>
-          <a:ln/>
-        </p:spPr>
-      </p:sp>
-      <p:sp>
-        <p:nvSpPr>
-          <p:cNvPr id="14" name="Text 12"/>
-          <p:cNvSpPr/>
-          <p:nvPr/>
-        </p:nvSpPr>
-        <p:spPr>
-          <a:xfrm>
-            <a:off x="5340096" y="923544"/>
-            <a:ext cx="3017520" cy="448056"/>
-          </a:xfrm>
-          <a:prstGeom prst="rect">
-            <a:avLst/>
-          </a:prstGeom>
-          <a:noFill/>
-          <a:ln/>
-        </p:spPr>
-        <p:txBody>
-          <a:bodyPr wrap="square" lIns="0" tIns="0" rIns="0" bIns="0" rtlCol="0" anchor="ctr"/>
-          <a:lstStyle/>
-          <a:p>
-            <a:pPr algn="ctr" indent="0" marL="0">
-              <a:buNone/>
-            </a:pPr>
-            <a:r>
-              <a:rPr lang="en-US" sz="1400" b="1" dirty="0">
-                <a:solidFill>
-                  <a:srgbClr val="D29922"/>
-                </a:solidFill>
-                <a:latin typeface="Calibri" pitchFamily="34" charset="0"/>
-                <a:ea typeface="Calibri" pitchFamily="34" charset="-122"/>
-                <a:cs typeface="Calibri" pitchFamily="34" charset="-120"/>
-              </a:rPr>
-              <a:t>Zone 2: Intermediate</a:t>
-            </a:r>
-            <a:endParaRPr lang="en-US" sz="1400" dirty="0"/>
-          </a:p>
-          <a:p>
-            <a:pPr algn="ctr" indent="0" marL="0">
-              <a:buNone/>
-            </a:pPr>
-            <a:r>
-              <a:rPr lang="en-US" sz="900" dirty="0">
-                <a:solidFill>
-                  <a:srgbClr val="8B949E"/>
-                </a:solidFill>
-                <a:latin typeface="Calibri" pitchFamily="34" charset="0"/>
-                <a:ea typeface="Calibri" pitchFamily="34" charset="-122"/>
-                <a:cs typeface="Calibri" pitchFamily="34" charset="-120"/>
-              </a:rPr>
-              <a:t>Collaborative • Repo/Team Level</a:t>
-            </a:r>
-            <a:endParaRPr lang="en-US" sz="1400" dirty="0"/>
-          </a:p>
-        </p:txBody>
-      </p:sp>
-      <p:sp>
-        <p:nvSpPr>
-          <p:cNvPr id="15" name="Shape 13"/>
-          <p:cNvSpPr/>
-          <p:nvPr/>
-        </p:nvSpPr>
-        <p:spPr>
-          <a:xfrm>
-            <a:off x="8467344" y="868680"/>
-            <a:ext cx="3017520" cy="502920"/>
-          </a:xfrm>
-          <a:prstGeom prst="rectangle">
-            <a:avLst/>
-          </a:prstGeom>
-          <a:solidFill>
-            <a:srgbClr val="161B22"/>
-          </a:solidFill>
-          <a:ln/>
-        </p:spPr>
-      </p:sp>
-      <p:sp>
-        <p:nvSpPr>
-          <p:cNvPr id="16" name="Shape 14"/>
-          <p:cNvSpPr/>
-          <p:nvPr/>
-        </p:nvSpPr>
-        <p:spPr>
-          <a:xfrm>
-            <a:off x="8467344" y="868680"/>
-            <a:ext cx="3017520" cy="36576"/>
-          </a:xfrm>
-          <a:prstGeom prst="rectangle">
-            <a:avLst/>
-          </a:prstGeom>
-          <a:solidFill>
-            <a:srgbClr val="F85149"/>
-          </a:solidFill>
-          <a:ln/>
-        </p:spPr>
-      </p:sp>
-      <p:sp>
-        <p:nvSpPr>
-          <p:cNvPr id="17" name="Text 15"/>
-          <p:cNvSpPr/>
-          <p:nvPr/>
-        </p:nvSpPr>
-        <p:spPr>
-          <a:xfrm>
-            <a:off x="8467344" y="923544"/>
-            <a:ext cx="3017520" cy="448056"/>
-          </a:xfrm>
-          <a:prstGeom prst="rect">
-            <a:avLst/>
-          </a:prstGeom>
-          <a:noFill/>
-          <a:ln/>
-        </p:spPr>
-        <p:txBody>
-          <a:bodyPr wrap="square" lIns="0" tIns="0" rIns="0" bIns="0" rtlCol="0" anchor="ctr"/>
-          <a:lstStyle/>
-          <a:p>
-            <a:pPr algn="ctr" indent="0" marL="0">
-              <a:buNone/>
-            </a:pPr>
-            <a:r>
-              <a:rPr lang="en-US" sz="1400" b="1" dirty="0">
-                <a:solidFill>
-                  <a:srgbClr val="F85149"/>
-                </a:solidFill>
-                <a:latin typeface="Calibri" pitchFamily="34" charset="0"/>
-                <a:ea typeface="Calibri" pitchFamily="34" charset="-122"/>
-                <a:cs typeface="Calibri" pitchFamily="34" charset="-120"/>
-              </a:rPr>
-              <a:t>Zone 3: Advanced</a:t>
-            </a:r>
-            <a:endParaRPr lang="en-US" sz="1400" dirty="0"/>
-          </a:p>
-          <a:p>
-            <a:pPr algn="ctr" indent="0" marL="0">
-              <a:buNone/>
-            </a:pPr>
-            <a:r>
-              <a:rPr lang="en-US" sz="900" dirty="0">
-                <a:solidFill>
-                  <a:srgbClr val="8B949E"/>
-                </a:solidFill>
-                <a:latin typeface="Calibri" pitchFamily="34" charset="0"/>
-                <a:ea typeface="Calibri" pitchFamily="34" charset="-122"/>
-                <a:cs typeface="Calibri" pitchFamily="34" charset="-120"/>
-              </a:rPr>
-              <a:t>Agentic • Architect/Org Level</a:t>
-            </a:r>
-            <a:endParaRPr lang="en-US" sz="1400" dirty="0"/>
-          </a:p>
-        </p:txBody>
-      </p:sp>
-      <p:sp>
-        <p:nvSpPr>
-          <p:cNvPr id="18" name="Shape 16"/>
-          <p:cNvSpPr/>
-          <p:nvPr/>
-        </p:nvSpPr>
-        <p:spPr>
-          <a:xfrm>
-            <a:off x="457200" y="1481328"/>
-            <a:ext cx="1645920" cy="1143000"/>
-          </a:xfrm>
-          <a:prstGeom prst="rectangle">
-            <a:avLst/>
-          </a:prstGeom>
-          <a:solidFill>
-            <a:srgbClr val="161B22"/>
-          </a:solidFill>
-          <a:ln/>
-        </p:spPr>
-      </p:sp>
-      <p:sp>
-        <p:nvSpPr>
-          <p:cNvPr id="19" name="Text 17"/>
-          <p:cNvSpPr/>
-          <p:nvPr/>
-        </p:nvSpPr>
-        <p:spPr>
-          <a:xfrm>
-            <a:off x="548640" y="1481328"/>
-            <a:ext cx="1463040" cy="1143000"/>
-          </a:xfrm>
-          <a:prstGeom prst="rect">
-            <a:avLst/>
-          </a:prstGeom>
-          <a:noFill/>
-          <a:ln/>
-        </p:spPr>
-        <p:txBody>
-          <a:bodyPr wrap="square" lIns="0" tIns="0" rIns="0" bIns="0" rtlCol="0" anchor="ctr"/>
-          <a:lstStyle/>
-          <a:p>
-            <a:pPr indent="0" marL="0">
-              <a:buNone/>
-            </a:pPr>
-            <a:r>
-              <a:rPr lang="en-US" sz="1100" b="1" dirty="0">
-                <a:solidFill>
-                  <a:srgbClr val="FFFFFF"/>
-                </a:solidFill>
-                <a:latin typeface="Calibri" pitchFamily="34" charset="0"/>
-                <a:ea typeface="Calibri" pitchFamily="34" charset="-122"/>
-                <a:cs typeface="Calibri" pitchFamily="34" charset="-120"/>
-              </a:rPr>
-              <a:t>IDE Workflow</a:t>
-            </a:r>
-            <a:endParaRPr lang="en-US" sz="1100" dirty="0"/>
-          </a:p>
-          <a:p>
-            <a:pPr indent="0" marL="0">
-              <a:buNone/>
-            </a:pPr>
-            <a:r>
-              <a:rPr lang="en-US" sz="900" dirty="0">
-                <a:solidFill>
-                  <a:srgbClr val="8B949E"/>
-                </a:solidFill>
-                <a:latin typeface="Calibri" pitchFamily="34" charset="0"/>
-                <a:ea typeface="Calibri" pitchFamily="34" charset="-122"/>
-                <a:cs typeface="Calibri" pitchFamily="34" charset="-120"/>
-              </a:rPr>
-              <a:t>The Editor</a:t>
-            </a:r>
-            <a:endParaRPr lang="en-US" sz="1100" dirty="0"/>
-          </a:p>
-        </p:txBody>
-      </p:sp>
-      <p:sp>
-        <p:nvSpPr>
-          <p:cNvPr id="20" name="Shape 18"/>
-          <p:cNvSpPr/>
-          <p:nvPr/>
-        </p:nvSpPr>
-        <p:spPr>
-          <a:xfrm>
-            <a:off x="2212848" y="1481328"/>
-            <a:ext cx="3017520" cy="1143000"/>
-          </a:xfrm>
-          <a:prstGeom prst="rectangle">
-            <a:avLst/>
-          </a:prstGeom>
-          <a:solidFill>
-            <a:srgbClr val="1C2333"/>
-          </a:solidFill>
-          <a:ln/>
-        </p:spPr>
-      </p:sp>
-      <p:sp>
-        <p:nvSpPr>
-          <p:cNvPr id="21" name="Shape 19"/>
-          <p:cNvSpPr/>
-          <p:nvPr/>
-        </p:nvSpPr>
-        <p:spPr>
-          <a:xfrm>
-            <a:off x="2212848" y="1481328"/>
-            <a:ext cx="36576" cy="1143000"/>
-          </a:xfrm>
-          <a:prstGeom prst="rectangle">
-            <a:avLst/>
-          </a:prstGeom>
-          <a:solidFill>
-            <a:srgbClr val="3FB950"/>
-          </a:solidFill>
-          <a:ln/>
-        </p:spPr>
-      </p:sp>
-      <p:sp>
-        <p:nvSpPr>
-          <p:cNvPr id="22" name="Text 20"/>
-          <p:cNvSpPr/>
-          <p:nvPr/>
-        </p:nvSpPr>
-        <p:spPr>
-          <a:xfrm>
-            <a:off x="2350008" y="1554480"/>
-            <a:ext cx="2788920" cy="996696"/>
-          </a:xfrm>
-          <a:prstGeom prst="rect">
-            <a:avLst/>
-          </a:prstGeom>
-          <a:noFill/>
-          <a:ln/>
-        </p:spPr>
-        <p:txBody>
-          <a:bodyPr wrap="square" lIns="0" tIns="0" rIns="0" bIns="0" rtlCol="0" anchor="t"/>
-          <a:lstStyle/>
-          <a:p>
-            <a:pPr indent="0" marL="0">
-              <a:buNone/>
-            </a:pPr>
-            <a:r>
-              <a:rPr lang="en-US" sz="1100" b="1" dirty="0">
-                <a:solidFill>
-                  <a:srgbClr val="FFFFFF"/>
-                </a:solidFill>
-                <a:latin typeface="Calibri" pitchFamily="34" charset="0"/>
-                <a:ea typeface="Calibri" pitchFamily="34" charset="-122"/>
-                <a:cs typeface="Calibri" pitchFamily="34" charset="-120"/>
-              </a:rPr>
-              <a:t>Ghost Text</a:t>
-            </a:r>
-            <a:endParaRPr lang="en-US" sz="1100" dirty="0"/>
-          </a:p>
-          <a:p>
-            <a:pPr indent="0" marL="0">
-              <a:buNone/>
-            </a:pPr>
-            <a:r>
-              <a:rPr lang="en-US" sz="900" dirty="0">
-                <a:solidFill>
-                  <a:srgbClr val="C9D1D9"/>
-                </a:solidFill>
-                <a:latin typeface="Calibri" pitchFamily="34" charset="0"/>
-                <a:ea typeface="Calibri" pitchFamily="34" charset="-122"/>
-                <a:cs typeface="Calibri" pitchFamily="34" charset="-120"/>
-              </a:rPr>
-              <a:t>Inline code and comment completion</a:t>
-            </a:r>
-            <a:endParaRPr lang="en-US" sz="1100" dirty="0"/>
-          </a:p>
-        </p:txBody>
-      </p:sp>
-      <p:sp>
-        <p:nvSpPr>
-          <p:cNvPr id="23" name="Shape 21"/>
-          <p:cNvSpPr/>
-          <p:nvPr/>
-        </p:nvSpPr>
-        <p:spPr>
-          <a:xfrm>
-            <a:off x="5340096" y="1481328"/>
-            <a:ext cx="3017520" cy="1143000"/>
-          </a:xfrm>
-          <a:prstGeom prst="rectangle">
-            <a:avLst/>
-          </a:prstGeom>
-          <a:solidFill>
-            <a:srgbClr val="1C2333"/>
-          </a:solidFill>
-          <a:ln/>
-        </p:spPr>
-      </p:sp>
-      <p:sp>
-        <p:nvSpPr>
-          <p:cNvPr id="24" name="Shape 22"/>
-          <p:cNvSpPr/>
-          <p:nvPr/>
-        </p:nvSpPr>
-        <p:spPr>
-          <a:xfrm>
-            <a:off x="5340096" y="1481328"/>
-            <a:ext cx="36576" cy="1143000"/>
-          </a:xfrm>
-          <a:prstGeom prst="rectangle">
-            <a:avLst/>
-          </a:prstGeom>
-          <a:solidFill>
-            <a:srgbClr val="D29922"/>
-          </a:solidFill>
-          <a:ln/>
-        </p:spPr>
-      </p:sp>
-      <p:sp>
-        <p:nvSpPr>
-          <p:cNvPr id="25" name="Text 23"/>
-          <p:cNvSpPr/>
-          <p:nvPr/>
-        </p:nvSpPr>
-        <p:spPr>
-          <a:xfrm>
-            <a:off x="5477256" y="1554480"/>
-            <a:ext cx="2788920" cy="996696"/>
-          </a:xfrm>
-          <a:prstGeom prst="rect">
-            <a:avLst/>
-          </a:prstGeom>
-          <a:noFill/>
-          <a:ln/>
-        </p:spPr>
-        <p:txBody>
-          <a:bodyPr wrap="square" lIns="0" tIns="0" rIns="0" bIns="0" rtlCol="0" anchor="t"/>
-          <a:lstStyle/>
-          <a:p>
-            <a:pPr indent="0" marL="0">
-              <a:buNone/>
-            </a:pPr>
-            <a:r>
-              <a:rPr lang="en-US" sz="1100" b="1" dirty="0">
-                <a:solidFill>
-                  <a:srgbClr val="FFFFFF"/>
-                </a:solidFill>
-                <a:latin typeface="Calibri" pitchFamily="34" charset="0"/>
-                <a:ea typeface="Calibri" pitchFamily="34" charset="-122"/>
-                <a:cs typeface="Calibri" pitchFamily="34" charset="-120"/>
-              </a:rPr>
-              <a:t>Chat &amp; Workspace</a:t>
-            </a:r>
-            <a:endParaRPr lang="en-US" sz="1100" dirty="0"/>
-          </a:p>
-          <a:p>
-            <a:pPr indent="0" marL="0">
-              <a:buNone/>
-            </a:pPr>
-            <a:r>
-              <a:rPr lang="en-US" sz="900" dirty="0">
-                <a:solidFill>
-                  <a:srgbClr val="C9D1D9"/>
-                </a:solidFill>
-                <a:latin typeface="Calibri" pitchFamily="34" charset="0"/>
-                <a:ea typeface="Calibri" pitchFamily="34" charset="-122"/>
-                <a:cs typeface="Calibri" pitchFamily="34" charset="-120"/>
-              </a:rPr>
-              <a:t>Multi-file context via @workspace. /explain and /tests commands</a:t>
-            </a:r>
-            <a:endParaRPr lang="en-US" sz="1100" dirty="0"/>
-          </a:p>
-        </p:txBody>
-      </p:sp>
-      <p:sp>
-        <p:nvSpPr>
-          <p:cNvPr id="26" name="Shape 24"/>
-          <p:cNvSpPr/>
-          <p:nvPr/>
-        </p:nvSpPr>
-        <p:spPr>
-          <a:xfrm>
-            <a:off x="8467344" y="1481328"/>
-            <a:ext cx="3017520" cy="1143000"/>
-          </a:xfrm>
-          <a:prstGeom prst="rectangle">
-            <a:avLst/>
-          </a:prstGeom>
-          <a:solidFill>
-            <a:srgbClr val="1C2333"/>
-          </a:solidFill>
-          <a:ln/>
-        </p:spPr>
-      </p:sp>
-      <p:sp>
-        <p:nvSpPr>
-          <p:cNvPr id="27" name="Shape 25"/>
-          <p:cNvSpPr/>
-          <p:nvPr/>
-        </p:nvSpPr>
-        <p:spPr>
-          <a:xfrm>
-            <a:off x="8467344" y="1481328"/>
-            <a:ext cx="36576" cy="1143000"/>
-          </a:xfrm>
-          <a:prstGeom prst="rectangle">
-            <a:avLst/>
-          </a:prstGeom>
-          <a:solidFill>
-            <a:srgbClr val="F85149"/>
-          </a:solidFill>
-          <a:ln/>
-        </p:spPr>
-      </p:sp>
-      <p:sp>
-        <p:nvSpPr>
-          <p:cNvPr id="28" name="Text 26"/>
-          <p:cNvSpPr/>
-          <p:nvPr/>
-        </p:nvSpPr>
-        <p:spPr>
-          <a:xfrm>
-            <a:off x="8604504" y="1554480"/>
-            <a:ext cx="2788920" cy="996696"/>
-          </a:xfrm>
-          <a:prstGeom prst="rect">
-            <a:avLst/>
-          </a:prstGeom>
-          <a:noFill/>
-          <a:ln/>
-        </p:spPr>
-        <p:txBody>
-          <a:bodyPr wrap="square" lIns="0" tIns="0" rIns="0" bIns="0" rtlCol="0" anchor="t"/>
-          <a:lstStyle/>
-          <a:p>
-            <a:pPr indent="0" marL="0">
-              <a:buNone/>
-            </a:pPr>
-            <a:r>
-              <a:rPr lang="en-US" sz="1100" b="1" dirty="0">
-                <a:solidFill>
-                  <a:srgbClr val="FFFFFF"/>
-                </a:solidFill>
-                <a:latin typeface="Calibri" pitchFamily="34" charset="0"/>
-                <a:ea typeface="Calibri" pitchFamily="34" charset="-122"/>
-                <a:cs typeface="Calibri" pitchFamily="34" charset="-120"/>
-              </a:rPr>
-              <a:t>Copilot Spaces</a:t>
-            </a:r>
-            <a:endParaRPr lang="en-US" sz="1100" dirty="0"/>
-          </a:p>
-          <a:p>
-            <a:pPr indent="0" marL="0">
-              <a:buNone/>
-            </a:pPr>
-            <a:r>
-              <a:rPr lang="en-US" sz="900" dirty="0">
-                <a:solidFill>
-                  <a:srgbClr val="C9D1D9"/>
-                </a:solidFill>
-                <a:latin typeface="Calibri" pitchFamily="34" charset="0"/>
-                <a:ea typeface="Calibri" pitchFamily="34" charset="-122"/>
-                <a:cs typeface="Calibri" pitchFamily="34" charset="-120"/>
-              </a:rPr>
-              <a:t>Visual workspace for architecture visualization and complex refactoring</a:t>
-            </a:r>
-            <a:endParaRPr lang="en-US" sz="1100" dirty="0"/>
-          </a:p>
-        </p:txBody>
-      </p:sp>
-      <p:sp>
-        <p:nvSpPr>
-          <p:cNvPr id="29" name="Shape 27"/>
-          <p:cNvSpPr/>
-          <p:nvPr/>
-        </p:nvSpPr>
-        <p:spPr>
-          <a:xfrm>
-            <a:off x="457200" y="2734056"/>
-            <a:ext cx="1645920" cy="1143000"/>
-          </a:xfrm>
-          <a:prstGeom prst="rectangle">
-            <a:avLst/>
-          </a:prstGeom>
-          <a:solidFill>
-            <a:srgbClr val="161B22"/>
-          </a:solidFill>
-          <a:ln/>
-        </p:spPr>
-      </p:sp>
-      <p:sp>
-        <p:nvSpPr>
-          <p:cNvPr id="30" name="Text 28"/>
-          <p:cNvSpPr/>
-          <p:nvPr/>
-        </p:nvSpPr>
-        <p:spPr>
-          <a:xfrm>
-            <a:off x="548640" y="2734056"/>
-            <a:ext cx="1463040" cy="1143000"/>
-          </a:xfrm>
-          <a:prstGeom prst="rect">
-            <a:avLst/>
-          </a:prstGeom>
-          <a:noFill/>
-          <a:ln/>
-        </p:spPr>
-        <p:txBody>
-          <a:bodyPr wrap="square" lIns="0" tIns="0" rIns="0" bIns="0" rtlCol="0" anchor="ctr"/>
-          <a:lstStyle/>
-          <a:p>
-            <a:pPr indent="0" marL="0">
-              <a:buNone/>
-            </a:pPr>
-            <a:r>
-              <a:rPr lang="en-US" sz="1100" b="1" dirty="0">
-                <a:solidFill>
-                  <a:srgbClr val="FFFFFF"/>
-                </a:solidFill>
-                <a:latin typeface="Calibri" pitchFamily="34" charset="0"/>
-                <a:ea typeface="Calibri" pitchFamily="34" charset="-122"/>
-                <a:cs typeface="Calibri" pitchFamily="34" charset="-120"/>
-              </a:rPr>
-              <a:t>Agentic Automation</a:t>
-            </a:r>
-            <a:endParaRPr lang="en-US" sz="1100" dirty="0"/>
-          </a:p>
-          <a:p>
-            <a:pPr indent="0" marL="0">
-              <a:buNone/>
-            </a:pPr>
-            <a:r>
-              <a:rPr lang="en-US" sz="900" dirty="0">
-                <a:solidFill>
-                  <a:srgbClr val="8B949E"/>
-                </a:solidFill>
-                <a:latin typeface="Calibri" pitchFamily="34" charset="0"/>
-                <a:ea typeface="Calibri" pitchFamily="34" charset="-122"/>
-                <a:cs typeface="Calibri" pitchFamily="34" charset="-120"/>
-              </a:rPr>
-              <a:t>CLI &amp; SDK</a:t>
-            </a:r>
-            <a:endParaRPr lang="en-US" sz="1100" dirty="0"/>
-          </a:p>
-        </p:txBody>
-      </p:sp>
-      <p:sp>
-        <p:nvSpPr>
-          <p:cNvPr id="31" name="Shape 29"/>
-          <p:cNvSpPr/>
-          <p:nvPr/>
-        </p:nvSpPr>
-        <p:spPr>
-          <a:xfrm>
-            <a:off x="2212848" y="2734056"/>
-            <a:ext cx="3017520" cy="1143000"/>
-          </a:xfrm>
-          <a:prstGeom prst="rectangle">
-            <a:avLst/>
-          </a:prstGeom>
-          <a:solidFill>
-            <a:srgbClr val="1C2333"/>
-          </a:solidFill>
-          <a:ln/>
-        </p:spPr>
-      </p:sp>
-      <p:sp>
-        <p:nvSpPr>
-          <p:cNvPr id="32" name="Shape 30"/>
-          <p:cNvSpPr/>
-          <p:nvPr/>
-        </p:nvSpPr>
-        <p:spPr>
-          <a:xfrm>
-            <a:off x="2212848" y="2734056"/>
-            <a:ext cx="36576" cy="1143000"/>
-          </a:xfrm>
-          <a:prstGeom prst="rectangle">
-            <a:avLst/>
-          </a:prstGeom>
-          <a:solidFill>
-            <a:srgbClr val="3FB950"/>
-          </a:solidFill>
-          <a:ln/>
-        </p:spPr>
-      </p:sp>
-      <p:sp>
-        <p:nvSpPr>
-          <p:cNvPr id="33" name="Text 31"/>
-          <p:cNvSpPr/>
-          <p:nvPr/>
-        </p:nvSpPr>
-        <p:spPr>
-          <a:xfrm>
-            <a:off x="2350008" y="2807208"/>
-            <a:ext cx="2788920" cy="996696"/>
-          </a:xfrm>
-          <a:prstGeom prst="rect">
-            <a:avLst/>
-          </a:prstGeom>
-          <a:noFill/>
-          <a:ln/>
-        </p:spPr>
-        <p:txBody>
-          <a:bodyPr wrap="square" lIns="0" tIns="0" rIns="0" bIns="0" rtlCol="0" anchor="t"/>
-          <a:lstStyle/>
-          <a:p>
-            <a:pPr indent="0" marL="0">
-              <a:buNone/>
-            </a:pPr>
-            <a:r>
-              <a:rPr lang="en-US" sz="1100" b="1" dirty="0">
-                <a:solidFill>
-                  <a:srgbClr val="FFFFFF"/>
-                </a:solidFill>
-                <a:latin typeface="Calibri" pitchFamily="34" charset="0"/>
-                <a:ea typeface="Calibri" pitchFamily="34" charset="-122"/>
-                <a:cs typeface="Calibri" pitchFamily="34" charset="-120"/>
-              </a:rPr>
-              <a:t>Command Suggestion</a:t>
-            </a:r>
-            <a:endParaRPr lang="en-US" sz="1100" dirty="0"/>
-          </a:p>
-          <a:p>
-            <a:pPr indent="0" marL="0">
-              <a:buNone/>
-            </a:pPr>
-            <a:r>
-              <a:rPr lang="en-US" sz="900" dirty="0">
-                <a:solidFill>
-                  <a:srgbClr val="C9D1D9"/>
-                </a:solidFill>
-                <a:latin typeface="Calibri" pitchFamily="34" charset="0"/>
-                <a:ea typeface="Calibri" pitchFamily="34" charset="-122"/>
-                <a:cs typeface="Calibri" pitchFamily="34" charset="-120"/>
-              </a:rPr>
-              <a:t>Basic gh copilot suggest in terminal</a:t>
-            </a:r>
-            <a:endParaRPr lang="en-US" sz="1100" dirty="0"/>
-          </a:p>
-        </p:txBody>
-      </p:sp>
-      <p:sp>
-        <p:nvSpPr>
-          <p:cNvPr id="34" name="Shape 32"/>
-          <p:cNvSpPr/>
-          <p:nvPr/>
-        </p:nvSpPr>
-        <p:spPr>
-          <a:xfrm>
-            <a:off x="5340096" y="2734056"/>
-            <a:ext cx="3017520" cy="1143000"/>
-          </a:xfrm>
-          <a:prstGeom prst="rectangle">
-            <a:avLst/>
-          </a:prstGeom>
-          <a:solidFill>
-            <a:srgbClr val="1C2333"/>
-          </a:solidFill>
-          <a:ln/>
-        </p:spPr>
-      </p:sp>
-      <p:sp>
-        <p:nvSpPr>
-          <p:cNvPr id="35" name="Shape 33"/>
-          <p:cNvSpPr/>
-          <p:nvPr/>
-        </p:nvSpPr>
-        <p:spPr>
-          <a:xfrm>
-            <a:off x="5340096" y="2734056"/>
-            <a:ext cx="36576" cy="1143000"/>
-          </a:xfrm>
-          <a:prstGeom prst="rectangle">
-            <a:avLst/>
-          </a:prstGeom>
-          <a:solidFill>
-            <a:srgbClr val="D29922"/>
-          </a:solidFill>
-          <a:ln/>
-        </p:spPr>
-      </p:sp>
-      <p:sp>
-        <p:nvSpPr>
-          <p:cNvPr id="36" name="Text 34"/>
-          <p:cNvSpPr/>
-          <p:nvPr/>
-        </p:nvSpPr>
-        <p:spPr>
-          <a:xfrm>
-            <a:off x="5477256" y="2807208"/>
-            <a:ext cx="2788920" cy="996696"/>
-          </a:xfrm>
-          <a:prstGeom prst="rect">
-            <a:avLst/>
-          </a:prstGeom>
-          <a:noFill/>
-          <a:ln/>
-        </p:spPr>
-        <p:txBody>
-          <a:bodyPr wrap="square" lIns="0" tIns="0" rIns="0" bIns="0" rtlCol="0" anchor="t"/>
-          <a:lstStyle/>
-          <a:p>
-            <a:pPr indent="0" marL="0">
-              <a:buNone/>
-            </a:pPr>
-            <a:r>
-              <a:rPr lang="en-US" sz="1100" b="1" dirty="0">
-                <a:solidFill>
-                  <a:srgbClr val="FFFFFF"/>
-                </a:solidFill>
-                <a:latin typeface="Calibri" pitchFamily="34" charset="0"/>
-                <a:ea typeface="Calibri" pitchFamily="34" charset="-122"/>
-                <a:cs typeface="Calibri" pitchFamily="34" charset="-120"/>
-              </a:rPr>
-              <a:t>Interactive CLI Chat</a:t>
-            </a:r>
-            <a:endParaRPr lang="en-US" sz="1100" dirty="0"/>
-          </a:p>
-          <a:p>
-            <a:pPr indent="0" marL="0">
-              <a:buNone/>
-            </a:pPr>
-            <a:r>
-              <a:rPr lang="en-US" sz="900" dirty="0">
-                <a:solidFill>
-                  <a:srgbClr val="C9D1D9"/>
-                </a:solidFill>
-                <a:latin typeface="Calibri" pitchFamily="34" charset="0"/>
-                <a:ea typeface="Calibri" pitchFamily="34" charset="-122"/>
-                <a:cs typeface="Calibri" pitchFamily="34" charset="-120"/>
-              </a:rPr>
-              <a:t>Debugging terminal errors and shell scripts</a:t>
-            </a:r>
-            <a:endParaRPr lang="en-US" sz="1100" dirty="0"/>
-          </a:p>
-        </p:txBody>
-      </p:sp>
-      <p:sp>
-        <p:nvSpPr>
-          <p:cNvPr id="37" name="Shape 35"/>
-          <p:cNvSpPr/>
-          <p:nvPr/>
-        </p:nvSpPr>
-        <p:spPr>
-          <a:xfrm>
-            <a:off x="8467344" y="2734056"/>
-            <a:ext cx="3017520" cy="1143000"/>
-          </a:xfrm>
-          <a:prstGeom prst="rectangle">
-            <a:avLst/>
-          </a:prstGeom>
-          <a:solidFill>
-            <a:srgbClr val="1C2333"/>
-          </a:solidFill>
-          <a:ln/>
-        </p:spPr>
-      </p:sp>
-      <p:sp>
-        <p:nvSpPr>
-          <p:cNvPr id="38" name="Shape 36"/>
-          <p:cNvSpPr/>
-          <p:nvPr/>
-        </p:nvSpPr>
-        <p:spPr>
-          <a:xfrm>
-            <a:off x="8467344" y="2734056"/>
-            <a:ext cx="36576" cy="1143000"/>
-          </a:xfrm>
-          <a:prstGeom prst="rectangle">
-            <a:avLst/>
-          </a:prstGeom>
-          <a:solidFill>
-            <a:srgbClr val="F85149"/>
-          </a:solidFill>
-          <a:ln/>
-        </p:spPr>
-      </p:sp>
-      <p:sp>
-        <p:nvSpPr>
-          <p:cNvPr id="39" name="Text 37"/>
-          <p:cNvSpPr/>
-          <p:nvPr/>
-        </p:nvSpPr>
-        <p:spPr>
-          <a:xfrm>
-            <a:off x="8604504" y="2807208"/>
-            <a:ext cx="2788920" cy="996696"/>
-          </a:xfrm>
-          <a:prstGeom prst="rect">
-            <a:avLst/>
-          </a:prstGeom>
-          <a:noFill/>
-          <a:ln/>
-        </p:spPr>
-        <p:txBody>
-          <a:bodyPr wrap="square" lIns="0" tIns="0" rIns="0" bIns="0" rtlCol="0" anchor="t"/>
-          <a:lstStyle/>
-          <a:p>
-            <a:pPr indent="0" marL="0">
-              <a:buNone/>
-            </a:pPr>
-            <a:r>
-              <a:rPr lang="en-US" sz="1100" b="1" dirty="0">
-                <a:solidFill>
-                  <a:srgbClr val="FFFFFF"/>
-                </a:solidFill>
-                <a:latin typeface="Calibri" pitchFamily="34" charset="0"/>
-                <a:ea typeface="Calibri" pitchFamily="34" charset="-122"/>
-                <a:cs typeface="Calibri" pitchFamily="34" charset="-120"/>
-              </a:rPr>
-              <a:t>CLI Autopilot Mode</a:t>
-            </a:r>
-            <a:endParaRPr lang="en-US" sz="1100" dirty="0"/>
-          </a:p>
-          <a:p>
-            <a:pPr indent="0" marL="0">
-              <a:buNone/>
-            </a:pPr>
-            <a:r>
-              <a:rPr lang="en-US" sz="900" dirty="0">
-                <a:solidFill>
-                  <a:srgbClr val="C9D1D9"/>
-                </a:solidFill>
-                <a:latin typeface="Calibri" pitchFamily="34" charset="0"/>
-                <a:ea typeface="Calibri" pitchFamily="34" charset="-122"/>
-                <a:cs typeface="Calibri" pitchFamily="34" charset="-120"/>
-              </a:rPr>
-              <a:t>Autonomous plan-act-review loops for complex file operations</a:t>
-            </a:r>
-            <a:endParaRPr lang="en-US" sz="1100" dirty="0"/>
-          </a:p>
-        </p:txBody>
-      </p:sp>
-      <p:sp>
-        <p:nvSpPr>
-          <p:cNvPr id="40" name="Shape 38"/>
-          <p:cNvSpPr/>
-          <p:nvPr/>
-        </p:nvSpPr>
-        <p:spPr>
-          <a:xfrm>
-            <a:off x="457200" y="3986784"/>
-            <a:ext cx="1645920" cy="1143000"/>
-          </a:xfrm>
-          <a:prstGeom prst="rectangle">
-            <a:avLst/>
-          </a:prstGeom>
-          <a:solidFill>
-            <a:srgbClr val="161B22"/>
-          </a:solidFill>
-          <a:ln/>
-        </p:spPr>
-      </p:sp>
-      <p:sp>
-        <p:nvSpPr>
-          <p:cNvPr id="41" name="Text 39"/>
-          <p:cNvSpPr/>
-          <p:nvPr/>
-        </p:nvSpPr>
-        <p:spPr>
-          <a:xfrm>
-            <a:off x="548640" y="3986784"/>
-            <a:ext cx="1463040" cy="1143000"/>
-          </a:xfrm>
-          <a:prstGeom prst="rect">
-            <a:avLst/>
-          </a:prstGeom>
-          <a:noFill/>
-          <a:ln/>
-        </p:spPr>
-        <p:txBody>
-          <a:bodyPr wrap="square" lIns="0" tIns="0" rIns="0" bIns="0" rtlCol="0" anchor="ctr"/>
-          <a:lstStyle/>
-          <a:p>
-            <a:pPr indent="0" marL="0">
-              <a:buNone/>
-            </a:pPr>
-            <a:r>
-              <a:rPr lang="en-US" sz="1100" b="1" dirty="0">
-                <a:solidFill>
-                  <a:srgbClr val="FFFFFF"/>
-                </a:solidFill>
-                <a:latin typeface="Calibri" pitchFamily="34" charset="0"/>
-                <a:ea typeface="Calibri" pitchFamily="34" charset="-122"/>
-                <a:cs typeface="Calibri" pitchFamily="34" charset="-120"/>
-              </a:rPr>
-              <a:t>Enterprise Knowledge</a:t>
-            </a:r>
-            <a:endParaRPr lang="en-US" sz="1100" dirty="0"/>
-          </a:p>
-          <a:p>
-            <a:pPr indent="0" marL="0">
-              <a:buNone/>
-            </a:pPr>
-            <a:r>
-              <a:rPr lang="en-US" sz="900" dirty="0">
-                <a:solidFill>
-                  <a:srgbClr val="8B949E"/>
-                </a:solidFill>
-                <a:latin typeface="Calibri" pitchFamily="34" charset="0"/>
-                <a:ea typeface="Calibri" pitchFamily="34" charset="-122"/>
-                <a:cs typeface="Calibri" pitchFamily="34" charset="-120"/>
-              </a:rPr>
-              <a:t>Governance</a:t>
-            </a:r>
-            <a:endParaRPr lang="en-US" sz="1100" dirty="0"/>
-          </a:p>
-        </p:txBody>
-      </p:sp>
-      <p:sp>
-        <p:nvSpPr>
-          <p:cNvPr id="42" name="Shape 40"/>
-          <p:cNvSpPr/>
-          <p:nvPr/>
-        </p:nvSpPr>
-        <p:spPr>
-          <a:xfrm>
-            <a:off x="2212848" y="3986784"/>
-            <a:ext cx="3017520" cy="1143000"/>
-          </a:xfrm>
-          <a:prstGeom prst="rectangle">
-            <a:avLst/>
-          </a:prstGeom>
-          <a:solidFill>
-            <a:srgbClr val="1C2333"/>
-          </a:solidFill>
-          <a:ln/>
-        </p:spPr>
-      </p:sp>
-      <p:sp>
-        <p:nvSpPr>
-          <p:cNvPr id="43" name="Shape 41"/>
-          <p:cNvSpPr/>
-          <p:nvPr/>
-        </p:nvSpPr>
-        <p:spPr>
-          <a:xfrm>
-            <a:off x="2212848" y="3986784"/>
-            <a:ext cx="36576" cy="1143000"/>
-          </a:xfrm>
-          <a:prstGeom prst="rectangle">
-            <a:avLst/>
-          </a:prstGeom>
-          <a:solidFill>
-            <a:srgbClr val="3FB950"/>
-          </a:solidFill>
-          <a:ln/>
-        </p:spPr>
-      </p:sp>
-      <p:sp>
-        <p:nvSpPr>
-          <p:cNvPr id="44" name="Text 42"/>
-          <p:cNvSpPr/>
-          <p:nvPr/>
-        </p:nvSpPr>
-        <p:spPr>
-          <a:xfrm>
-            <a:off x="2350008" y="4059936"/>
-            <a:ext cx="2788920" cy="996696"/>
-          </a:xfrm>
-          <a:prstGeom prst="rect">
-            <a:avLst/>
-          </a:prstGeom>
-          <a:noFill/>
-          <a:ln/>
-        </p:spPr>
-        <p:txBody>
-          <a:bodyPr wrap="square" lIns="0" tIns="0" rIns="0" bIns="0" rtlCol="0" anchor="t"/>
-          <a:lstStyle/>
-          <a:p>
-            <a:pPr indent="0" marL="0">
-              <a:buNone/>
-            </a:pPr>
-            <a:r>
-              <a:rPr lang="en-US" sz="1100" b="1" dirty="0">
-                <a:solidFill>
-                  <a:srgbClr val="FFFFFF"/>
-                </a:solidFill>
-                <a:latin typeface="Calibri" pitchFamily="34" charset="0"/>
-                <a:ea typeface="Calibri" pitchFamily="34" charset="-122"/>
-                <a:cs typeface="Calibri" pitchFamily="34" charset="-120"/>
-              </a:rPr>
-              <a:t>Content Exclusion</a:t>
-            </a:r>
-            <a:endParaRPr lang="en-US" sz="1100" dirty="0"/>
-          </a:p>
-          <a:p>
-            <a:pPr indent="0" marL="0">
-              <a:buNone/>
-            </a:pPr>
-            <a:r>
-              <a:rPr lang="en-US" sz="900" dirty="0">
-                <a:solidFill>
-                  <a:srgbClr val="C9D1D9"/>
-                </a:solidFill>
-                <a:latin typeface="Calibri" pitchFamily="34" charset="0"/>
-                <a:ea typeface="Calibri" pitchFamily="34" charset="-122"/>
-                <a:cs typeface="Calibri" pitchFamily="34" charset="-120"/>
-              </a:rPr>
-              <a:t>Basic safety controls on file visibility</a:t>
-            </a:r>
-            <a:endParaRPr lang="en-US" sz="1100" dirty="0"/>
-          </a:p>
-        </p:txBody>
-      </p:sp>
-      <p:sp>
-        <p:nvSpPr>
-          <p:cNvPr id="45" name="Shape 43"/>
-          <p:cNvSpPr/>
-          <p:nvPr/>
-        </p:nvSpPr>
-        <p:spPr>
-          <a:xfrm>
-            <a:off x="5340096" y="3986784"/>
-            <a:ext cx="3017520" cy="1143000"/>
-          </a:xfrm>
-          <a:prstGeom prst="rectangle">
-            <a:avLst/>
-          </a:prstGeom>
-          <a:solidFill>
-            <a:srgbClr val="1C2333"/>
-          </a:solidFill>
-          <a:ln/>
-        </p:spPr>
-      </p:sp>
-      <p:sp>
-        <p:nvSpPr>
-          <p:cNvPr id="46" name="Shape 44"/>
-          <p:cNvSpPr/>
-          <p:nvPr/>
-        </p:nvSpPr>
-        <p:spPr>
-          <a:xfrm>
-            <a:off x="5340096" y="3986784"/>
-            <a:ext cx="36576" cy="1143000"/>
-          </a:xfrm>
-          <a:prstGeom prst="rectangle">
-            <a:avLst/>
-          </a:prstGeom>
-          <a:solidFill>
-            <a:srgbClr val="D29922"/>
-          </a:solidFill>
-          <a:ln/>
-        </p:spPr>
-      </p:sp>
-      <p:sp>
-        <p:nvSpPr>
-          <p:cNvPr id="47" name="Text 45"/>
-          <p:cNvSpPr/>
-          <p:nvPr/>
-        </p:nvSpPr>
-        <p:spPr>
-          <a:xfrm>
-            <a:off x="5477256" y="4059936"/>
-            <a:ext cx="2788920" cy="996696"/>
-          </a:xfrm>
-          <a:prstGeom prst="rect">
-            <a:avLst/>
-          </a:prstGeom>
-          <a:noFill/>
-          <a:ln/>
-        </p:spPr>
-        <p:txBody>
-          <a:bodyPr wrap="square" lIns="0" tIns="0" rIns="0" bIns="0" rtlCol="0" anchor="t"/>
-          <a:lstStyle/>
-          <a:p>
-            <a:pPr indent="0" marL="0">
-              <a:buNone/>
-            </a:pPr>
-            <a:r>
-              <a:rPr lang="en-US" sz="1100" b="1" dirty="0">
-                <a:solidFill>
-                  <a:srgbClr val="FFFFFF"/>
-                </a:solidFill>
-                <a:latin typeface="Calibri" pitchFamily="34" charset="0"/>
-                <a:ea typeface="Calibri" pitchFamily="34" charset="-122"/>
-                <a:cs typeface="Calibri" pitchFamily="34" charset="-120"/>
-              </a:rPr>
-              <a:t>Knowledge Bases</a:t>
-            </a:r>
-            <a:endParaRPr lang="en-US" sz="1100" dirty="0"/>
-          </a:p>
-          <a:p>
-            <a:pPr indent="0" marL="0">
-              <a:buNone/>
-            </a:pPr>
-            <a:r>
-              <a:rPr lang="en-US" sz="900" dirty="0">
-                <a:solidFill>
-                  <a:srgbClr val="C9D1D9"/>
-                </a:solidFill>
-                <a:latin typeface="Calibri" pitchFamily="34" charset="0"/>
-                <a:ea typeface="Calibri" pitchFamily="34" charset="-122"/>
-                <a:cs typeface="Calibri" pitchFamily="34" charset="-120"/>
-              </a:rPr>
-              <a:t>Indexing internal docs/Wikis for contextual answers</a:t>
-            </a:r>
-            <a:endParaRPr lang="en-US" sz="1100" dirty="0"/>
-          </a:p>
-        </p:txBody>
-      </p:sp>
-      <p:sp>
-        <p:nvSpPr>
-          <p:cNvPr id="48" name="Shape 46"/>
-          <p:cNvSpPr/>
-          <p:nvPr/>
-        </p:nvSpPr>
-        <p:spPr>
-          <a:xfrm>
-            <a:off x="8467344" y="3986784"/>
-            <a:ext cx="3017520" cy="1143000"/>
-          </a:xfrm>
-          <a:prstGeom prst="rectangle">
-            <a:avLst/>
-          </a:prstGeom>
-          <a:solidFill>
-            <a:srgbClr val="1C2333"/>
-          </a:solidFill>
-          <a:ln/>
-        </p:spPr>
-      </p:sp>
-      <p:sp>
-        <p:nvSpPr>
-          <p:cNvPr id="49" name="Shape 47"/>
-          <p:cNvSpPr/>
-          <p:nvPr/>
-        </p:nvSpPr>
-        <p:spPr>
-          <a:xfrm>
-            <a:off x="8467344" y="3986784"/>
-            <a:ext cx="36576" cy="1143000"/>
-          </a:xfrm>
-          <a:prstGeom prst="rectangle">
-            <a:avLst/>
-          </a:prstGeom>
-          <a:solidFill>
-            <a:srgbClr val="F85149"/>
-          </a:solidFill>
-          <a:ln/>
-        </p:spPr>
-      </p:sp>
-      <p:sp>
-        <p:nvSpPr>
-          <p:cNvPr id="50" name="Text 48"/>
-          <p:cNvSpPr/>
-          <p:nvPr/>
-        </p:nvSpPr>
-        <p:spPr>
-          <a:xfrm>
-            <a:off x="8604504" y="4059936"/>
-            <a:ext cx="2788920" cy="996696"/>
-          </a:xfrm>
-          <a:prstGeom prst="rect">
-            <a:avLst/>
-          </a:prstGeom>
-          <a:noFill/>
-          <a:ln/>
-        </p:spPr>
-        <p:txBody>
-          <a:bodyPr wrap="square" lIns="0" tIns="0" rIns="0" bIns="0" rtlCol="0" anchor="t"/>
-          <a:lstStyle/>
-          <a:p>
-            <a:pPr indent="0" marL="0">
-              <a:buNone/>
-            </a:pPr>
-            <a:r>
-              <a:rPr lang="en-US" sz="1100" b="1" dirty="0">
-                <a:solidFill>
-                  <a:srgbClr val="FFFFFF"/>
-                </a:solidFill>
-                <a:latin typeface="Calibri" pitchFamily="34" charset="0"/>
-                <a:ea typeface="Calibri" pitchFamily="34" charset="-122"/>
-                <a:cs typeface="Calibri" pitchFamily="34" charset="-120"/>
-              </a:rPr>
-              <a:t>AI Code Review Agent</a:t>
-            </a:r>
-            <a:endParaRPr lang="en-US" sz="1100" dirty="0"/>
-          </a:p>
-          <a:p>
-            <a:pPr indent="0" marL="0">
-              <a:buNone/>
-            </a:pPr>
-            <a:r>
-              <a:rPr lang="en-US" sz="900" dirty="0">
-                <a:solidFill>
-                  <a:srgbClr val="C9D1D9"/>
-                </a:solidFill>
-                <a:latin typeface="Calibri" pitchFamily="34" charset="0"/>
-                <a:ea typeface="Calibri" pitchFamily="34" charset="-122"/>
-                <a:cs typeface="Calibri" pitchFamily="34" charset="-120"/>
-              </a:rPr>
-              <a:t>Autonomous security and standards auditing on PRs</a:t>
-            </a:r>
-            <a:endParaRPr lang="en-US" sz="1100" dirty="0"/>
-          </a:p>
-        </p:txBody>
-      </p:sp>
-      <p:sp>
-        <p:nvSpPr>
-          <p:cNvPr id="51" name="Shape 49"/>
-          <p:cNvSpPr/>
-          <p:nvPr/>
-        </p:nvSpPr>
-        <p:spPr>
-          <a:xfrm>
-            <a:off x="457200" y="5239512"/>
-            <a:ext cx="1645920" cy="1143000"/>
-          </a:xfrm>
-          <a:prstGeom prst="rectangle">
-            <a:avLst/>
-          </a:prstGeom>
-          <a:solidFill>
-            <a:srgbClr val="161B22"/>
-          </a:solidFill>
-          <a:ln/>
-        </p:spPr>
-      </p:sp>
-      <p:sp>
-        <p:nvSpPr>
-          <p:cNvPr id="52" name="Text 50"/>
-          <p:cNvSpPr/>
-          <p:nvPr/>
-        </p:nvSpPr>
-        <p:spPr>
-          <a:xfrm>
-            <a:off x="548640" y="5239512"/>
-            <a:ext cx="1463040" cy="1143000"/>
-          </a:xfrm>
-          <a:prstGeom prst="rect">
-            <a:avLst/>
-          </a:prstGeom>
-          <a:noFill/>
-          <a:ln/>
-        </p:spPr>
-        <p:txBody>
-          <a:bodyPr wrap="square" lIns="0" tIns="0" rIns="0" bIns="0" rtlCol="0" anchor="ctr"/>
-          <a:lstStyle/>
-          <a:p>
-            <a:pPr indent="0" marL="0">
-              <a:buNone/>
-            </a:pPr>
-            <a:r>
-              <a:rPr lang="en-US" sz="1100" b="1" dirty="0">
-                <a:solidFill>
-                  <a:srgbClr val="FFFFFF"/>
-                </a:solidFill>
-                <a:latin typeface="Calibri" pitchFamily="34" charset="0"/>
-                <a:ea typeface="Calibri" pitchFamily="34" charset="-122"/>
-                <a:cs typeface="Calibri" pitchFamily="34" charset="-120"/>
-              </a:rPr>
-              <a:t>Extensions &amp; Modernization</a:t>
-            </a:r>
-            <a:endParaRPr lang="en-US" sz="1100" dirty="0"/>
-          </a:p>
-          <a:p>
-            <a:pPr indent="0" marL="0">
-              <a:buNone/>
-            </a:pPr>
-            <a:r>
-              <a:rPr lang="en-US" sz="900" dirty="0">
-                <a:solidFill>
-                  <a:srgbClr val="8B949E"/>
-                </a:solidFill>
-                <a:latin typeface="Calibri" pitchFamily="34" charset="0"/>
-                <a:ea typeface="Calibri" pitchFamily="34" charset="-122"/>
-                <a:cs typeface="Calibri" pitchFamily="34" charset="-120"/>
-              </a:rPr>
-              <a:t>Ecosystem</a:t>
-            </a:r>
-            <a:endParaRPr lang="en-US" sz="1100" dirty="0"/>
-          </a:p>
-        </p:txBody>
-      </p:sp>
-      <p:sp>
-        <p:nvSpPr>
-          <p:cNvPr id="53" name="Shape 51"/>
-          <p:cNvSpPr/>
-          <p:nvPr/>
-        </p:nvSpPr>
-        <p:spPr>
-          <a:xfrm>
-            <a:off x="2212848" y="5239512"/>
-            <a:ext cx="3017520" cy="1143000"/>
-          </a:xfrm>
-          <a:prstGeom prst="rectangle">
-            <a:avLst/>
-          </a:prstGeom>
-          <a:solidFill>
-            <a:srgbClr val="1C2333"/>
-          </a:solidFill>
-          <a:ln/>
-        </p:spPr>
-      </p:sp>
-      <p:sp>
-        <p:nvSpPr>
-          <p:cNvPr id="54" name="Shape 52"/>
-          <p:cNvSpPr/>
-          <p:nvPr/>
-        </p:nvSpPr>
-        <p:spPr>
-          <a:xfrm>
-            <a:off x="2212848" y="5239512"/>
-            <a:ext cx="36576" cy="1143000"/>
-          </a:xfrm>
-          <a:prstGeom prst="rectangle">
-            <a:avLst/>
-          </a:prstGeom>
-          <a:solidFill>
-            <a:srgbClr val="3FB950"/>
-          </a:solidFill>
-          <a:ln/>
-        </p:spPr>
-      </p:sp>
-      <p:sp>
-        <p:nvSpPr>
-          <p:cNvPr id="55" name="Text 53"/>
-          <p:cNvSpPr/>
-          <p:nvPr/>
-        </p:nvSpPr>
-        <p:spPr>
-          <a:xfrm>
-            <a:off x="2350008" y="5312664"/>
-            <a:ext cx="2788920" cy="996696"/>
-          </a:xfrm>
-          <a:prstGeom prst="rect">
-            <a:avLst/>
-          </a:prstGeom>
-          <a:noFill/>
-          <a:ln/>
-        </p:spPr>
-        <p:txBody>
-          <a:bodyPr wrap="square" lIns="0" tIns="0" rIns="0" bIns="0" rtlCol="0" anchor="t"/>
-          <a:lstStyle/>
-          <a:p>
-            <a:pPr indent="0" marL="0">
-              <a:buNone/>
-            </a:pPr>
-            <a:r>
-              <a:rPr lang="en-US" sz="1100" b="1" dirty="0">
-                <a:solidFill>
-                  <a:srgbClr val="FFFFFF"/>
-                </a:solidFill>
-                <a:latin typeface="Calibri" pitchFamily="34" charset="0"/>
-                <a:ea typeface="Calibri" pitchFamily="34" charset="-122"/>
-                <a:cs typeface="Calibri" pitchFamily="34" charset="-120"/>
-              </a:rPr>
-              <a:t>Slash Commands</a:t>
-            </a:r>
-            <a:endParaRPr lang="en-US" sz="1100" dirty="0"/>
-          </a:p>
-          <a:p>
-            <a:pPr indent="0" marL="0">
-              <a:buNone/>
-            </a:pPr>
-            <a:r>
-              <a:rPr lang="en-US" sz="900" dirty="0">
-                <a:solidFill>
-                  <a:srgbClr val="C9D1D9"/>
-                </a:solidFill>
-                <a:latin typeface="Calibri" pitchFamily="34" charset="0"/>
-                <a:ea typeface="Calibri" pitchFamily="34" charset="-122"/>
-                <a:cs typeface="Calibri" pitchFamily="34" charset="-120"/>
-              </a:rPr>
-              <a:t>Basic code refactoring (/fix)</a:t>
-            </a:r>
-            <a:endParaRPr lang="en-US" sz="1100" dirty="0"/>
-          </a:p>
-        </p:txBody>
-      </p:sp>
-      <p:sp>
-        <p:nvSpPr>
-          <p:cNvPr id="56" name="Shape 54"/>
-          <p:cNvSpPr/>
-          <p:nvPr/>
-        </p:nvSpPr>
-        <p:spPr>
-          <a:xfrm>
-            <a:off x="5340096" y="5239512"/>
-            <a:ext cx="3017520" cy="1143000"/>
-          </a:xfrm>
-          <a:prstGeom prst="rectangle">
-            <a:avLst/>
-          </a:prstGeom>
-          <a:solidFill>
-            <a:srgbClr val="1C2333"/>
-          </a:solidFill>
-          <a:ln/>
-        </p:spPr>
-      </p:sp>
-      <p:sp>
-        <p:nvSpPr>
-          <p:cNvPr id="57" name="Shape 55"/>
-          <p:cNvSpPr/>
-          <p:nvPr/>
-        </p:nvSpPr>
-        <p:spPr>
-          <a:xfrm>
-            <a:off x="5340096" y="5239512"/>
-            <a:ext cx="36576" cy="1143000"/>
-          </a:xfrm>
-          <a:prstGeom prst="rectangle">
-            <a:avLst/>
-          </a:prstGeom>
-          <a:solidFill>
-            <a:srgbClr val="D29922"/>
-          </a:solidFill>
-          <a:ln/>
-        </p:spPr>
-      </p:sp>
-      <p:sp>
-        <p:nvSpPr>
-          <p:cNvPr id="58" name="Text 56"/>
-          <p:cNvSpPr/>
-          <p:nvPr/>
-        </p:nvSpPr>
-        <p:spPr>
-          <a:xfrm>
-            <a:off x="5477256" y="5312664"/>
-            <a:ext cx="2788920" cy="996696"/>
-          </a:xfrm>
-          <a:prstGeom prst="rect">
-            <a:avLst/>
-          </a:prstGeom>
-          <a:noFill/>
-          <a:ln/>
-        </p:spPr>
-        <p:txBody>
-          <a:bodyPr wrap="square" lIns="0" tIns="0" rIns="0" bIns="0" rtlCol="0" anchor="t"/>
-          <a:lstStyle/>
-          <a:p>
-            <a:pPr indent="0" marL="0">
-              <a:buNone/>
-            </a:pPr>
-            <a:r>
-              <a:rPr lang="en-US" sz="1100" b="1" dirty="0">
-                <a:solidFill>
-                  <a:srgbClr val="FFFFFF"/>
-                </a:solidFill>
-                <a:latin typeface="Calibri" pitchFamily="34" charset="0"/>
-                <a:ea typeface="Calibri" pitchFamily="34" charset="-122"/>
-                <a:cs typeface="Calibri" pitchFamily="34" charset="-120"/>
-              </a:rPr>
-              <a:t>1st Party Extensions</a:t>
-            </a:r>
-            <a:endParaRPr lang="en-US" sz="1100" dirty="0"/>
-          </a:p>
-          <a:p>
-            <a:pPr indent="0" marL="0">
-              <a:buNone/>
-            </a:pPr>
-            <a:r>
-              <a:rPr lang="en-US" sz="900" dirty="0">
-                <a:solidFill>
-                  <a:srgbClr val="C9D1D9"/>
-                </a:solidFill>
-                <a:latin typeface="Calibri" pitchFamily="34" charset="0"/>
-                <a:ea typeface="Calibri" pitchFamily="34" charset="-122"/>
-                <a:cs typeface="Calibri" pitchFamily="34" charset="-120"/>
-              </a:rPr>
-              <a:t>Connecting to Azure Database, Teams, and more</a:t>
-            </a:r>
-            <a:endParaRPr lang="en-US" sz="1100" dirty="0"/>
-          </a:p>
-        </p:txBody>
-      </p:sp>
-      <p:sp>
-        <p:nvSpPr>
-          <p:cNvPr id="59" name="Shape 57"/>
-          <p:cNvSpPr/>
-          <p:nvPr/>
-        </p:nvSpPr>
-        <p:spPr>
-          <a:xfrm>
-            <a:off x="8467344" y="5239512"/>
-            <a:ext cx="3017520" cy="1143000"/>
-          </a:xfrm>
-          <a:prstGeom prst="rectangle">
-            <a:avLst/>
-          </a:prstGeom>
-          <a:solidFill>
-            <a:srgbClr val="1C2333"/>
-          </a:solidFill>
-          <a:ln/>
-        </p:spPr>
-      </p:sp>
-      <p:sp>
-        <p:nvSpPr>
-          <p:cNvPr id="60" name="Shape 58"/>
-          <p:cNvSpPr/>
-          <p:nvPr/>
-        </p:nvSpPr>
-        <p:spPr>
-          <a:xfrm>
-            <a:off x="8467344" y="5239512"/>
-            <a:ext cx="36576" cy="1143000"/>
-          </a:xfrm>
-          <a:prstGeom prst="rectangle">
-            <a:avLst/>
-          </a:prstGeom>
-          <a:solidFill>
-            <a:srgbClr val="F85149"/>
-          </a:solidFill>
-          <a:ln/>
-        </p:spPr>
-      </p:sp>
-      <p:sp>
-        <p:nvSpPr>
-          <p:cNvPr id="61" name="Text 59"/>
-          <p:cNvSpPr/>
-          <p:nvPr/>
-        </p:nvSpPr>
-        <p:spPr>
-          <a:xfrm>
-            <a:off x="8604504" y="5312664"/>
-            <a:ext cx="2788920" cy="996696"/>
-          </a:xfrm>
-          <a:prstGeom prst="rect">
-            <a:avLst/>
-          </a:prstGeom>
-          <a:noFill/>
-          <a:ln/>
-        </p:spPr>
-        <p:txBody>
-          <a:bodyPr wrap="square" lIns="0" tIns="0" rIns="0" bIns="0" rtlCol="0" anchor="t"/>
-          <a:lstStyle/>
-          <a:p>
-            <a:pPr indent="0" marL="0">
-              <a:buNone/>
-            </a:pPr>
-            <a:r>
-              <a:rPr lang="en-US" sz="1100" b="1" dirty="0">
-                <a:solidFill>
-                  <a:srgbClr val="FFFFFF"/>
-                </a:solidFill>
-                <a:latin typeface="Calibri" pitchFamily="34" charset="0"/>
-                <a:ea typeface="Calibri" pitchFamily="34" charset="-122"/>
-                <a:cs typeface="Calibri" pitchFamily="34" charset="-120"/>
-              </a:rPr>
-              <a:t>Modernization Agent</a:t>
-            </a:r>
-            <a:endParaRPr lang="en-US" sz="1100" dirty="0"/>
-          </a:p>
-          <a:p>
-            <a:pPr indent="0" marL="0">
-              <a:buNone/>
-            </a:pPr>
-            <a:r>
-              <a:rPr lang="en-US" sz="900" dirty="0">
-                <a:solidFill>
-                  <a:srgbClr val="C9D1D9"/>
-                </a:solidFill>
-                <a:latin typeface="Calibri" pitchFamily="34" charset="0"/>
-                <a:ea typeface="Calibri" pitchFamily="34" charset="-122"/>
-                <a:cs typeface="Calibri" pitchFamily="34" charset="-120"/>
-              </a:rPr>
-              <a:t>Assess → Plan → Execute: .NET/Java to Azure migration + Vibe Coding</a:t>
-            </a:r>
-            <a:endParaRPr lang="en-US" sz="1100" dirty="0"/>
-          </a:p>
-        </p:txBody>
-      </p:sp>
-      <p:sp>
-        <p:nvSpPr>
-          <p:cNvPr id="62" name="Text 60"/>
-          <p:cNvSpPr/>
-          <p:nvPr/>
-        </p:nvSpPr>
-        <p:spPr>
-          <a:xfrm>
-            <a:off x="2212848" y="6537960"/>
-            <a:ext cx="3017520" cy="228600"/>
-          </a:xfrm>
-          <a:prstGeom prst="rect">
-            <a:avLst/>
-          </a:prstGeom>
-          <a:noFill/>
-          <a:ln/>
-        </p:spPr>
-        <p:txBody>
-          <a:bodyPr wrap="square" lIns="0" tIns="0" rIns="0" bIns="0" rtlCol="0" anchor="ctr"/>
-          <a:lstStyle/>
-          <a:p>
-            <a:pPr algn="ctr" indent="0" marL="0">
-              <a:buNone/>
-            </a:pPr>
-            <a:r>
-              <a:rPr lang="en-US" sz="800" dirty="0">
-                <a:solidFill>
-                  <a:srgbClr val="8B949E"/>
-                </a:solidFill>
-                <a:latin typeface="Calibri" pitchFamily="34" charset="0"/>
-                <a:ea typeface="Calibri" pitchFamily="34" charset="-122"/>
-                <a:cs typeface="Calibri" pitchFamily="34" charset="-120"/>
-              </a:rPr>
-              <a:t>◀ Reactive • Single-task</a:t>
-            </a:r>
-            <a:endParaRPr lang="en-US" sz="800" dirty="0"/>
-          </a:p>
-        </p:txBody>
-      </p:sp>
-      <p:sp>
-        <p:nvSpPr>
-          <p:cNvPr id="63" name="Text 61"/>
-          <p:cNvSpPr/>
-          <p:nvPr/>
-        </p:nvSpPr>
-        <p:spPr>
-          <a:xfrm>
-            <a:off x="5340096" y="6537960"/>
-            <a:ext cx="3017520" cy="228600"/>
-          </a:xfrm>
-          <a:prstGeom prst="rect">
-            <a:avLst/>
-          </a:prstGeom>
-          <a:noFill/>
-          <a:ln/>
-        </p:spPr>
-        <p:txBody>
-          <a:bodyPr wrap="square" lIns="0" tIns="0" rIns="0" bIns="0" rtlCol="0" anchor="ctr"/>
-          <a:lstStyle/>
-          <a:p>
-            <a:pPr algn="ctr" indent="0" marL="0">
-              <a:buNone/>
-            </a:pPr>
-            <a:r>
-              <a:rPr lang="en-US" sz="800" dirty="0">
-                <a:solidFill>
-                  <a:srgbClr val="8B949E"/>
-                </a:solidFill>
-                <a:latin typeface="Calibri" pitchFamily="34" charset="0"/>
-                <a:ea typeface="Calibri" pitchFamily="34" charset="-122"/>
-                <a:cs typeface="Calibri" pitchFamily="34" charset="-120"/>
-              </a:rPr>
-              <a:t>Multi-file • Context-aware</a:t>
-            </a:r>
-            <a:endParaRPr lang="en-US" sz="800" dirty="0"/>
-          </a:p>
-        </p:txBody>
-      </p:sp>
-      <p:sp>
-        <p:nvSpPr>
-          <p:cNvPr id="64" name="Text 62"/>
-          <p:cNvSpPr/>
-          <p:nvPr/>
-        </p:nvSpPr>
-        <p:spPr>
-          <a:xfrm>
-            <a:off x="8467344" y="6537960"/>
-            <a:ext cx="3017520" cy="228600"/>
-          </a:xfrm>
-          <a:prstGeom prst="rect">
-            <a:avLst/>
-          </a:prstGeom>
-          <a:noFill/>
-          <a:ln/>
-        </p:spPr>
-        <p:txBody>
-          <a:bodyPr wrap="square" lIns="0" tIns="0" rIns="0" bIns="0" rtlCol="0" anchor="ctr"/>
-          <a:lstStyle/>
-          <a:p>
-            <a:pPr algn="ctr" indent="0" marL="0">
-              <a:buNone/>
-            </a:pPr>
-            <a:r>
-              <a:rPr lang="en-US" sz="800" dirty="0">
-                <a:solidFill>
-                  <a:srgbClr val="8B949E"/>
-                </a:solidFill>
-                <a:latin typeface="Calibri" pitchFamily="34" charset="0"/>
-                <a:ea typeface="Calibri" pitchFamily="34" charset="-122"/>
-                <a:cs typeface="Calibri" pitchFamily="34" charset="-120"/>
-              </a:rPr>
-              <a:t>Autonomous • Goal-oriented ▶</a:t>
-            </a:r>
-            <a:endParaRPr lang="en-US" sz="800" dirty="0"/>
-          </a:p>
-        </p:txBody>
-      </p:sp>
-      <p:sp>
-        <p:nvSpPr>
-          <p:cNvPr id="65" name="Text 63"/>
-          <p:cNvSpPr/>
-          <p:nvPr/>
-        </p:nvSpPr>
-        <p:spPr>
-          <a:xfrm>
-            <a:off x="457200" y="6537960"/>
-            <a:ext cx="1645920" cy="228600"/>
-          </a:xfrm>
-          <a:prstGeom prst="rect">
-            <a:avLst/>
-          </a:prstGeom>
-          <a:noFill/>
-          <a:ln/>
-        </p:spPr>
-        <p:txBody>
-          <a:bodyPr wrap="square" lIns="0" tIns="0" rIns="0" bIns="0" rtlCol="0" anchor="ctr"/>
-          <a:lstStyle/>
-          <a:p>
-            <a:pPr algn="ctr" indent="0" marL="0">
-              <a:buNone/>
-            </a:pPr>
-            <a:r>
-              <a:rPr lang="en-US" sz="800" b="1" dirty="0">
-                <a:solidFill>
-                  <a:srgbClr val="2F81F7"/>
-                </a:solidFill>
-                <a:latin typeface="Calibri" pitchFamily="34" charset="0"/>
-                <a:ea typeface="Calibri" pitchFamily="34" charset="-122"/>
-                <a:cs typeface="Calibri" pitchFamily="34" charset="-120"/>
-              </a:rPr>
-              <a:t>⚡ 4S Prompting Method</a:t>
-            </a:r>
-            <a:endParaRPr lang="en-US" sz="800" dirty="0"/>
+          <a:ln>
+            <a:noFill/>
+          </a:ln>
+        </p:spPr>
+        <p:txBody>
+          <a:bodyPr/>
+          <a:lstStyle/>
+          <a:p>
+            <a:endParaRPr lang="en-US"/>
           </a:p>
         </p:txBody>
       </p:sp>
     </p:spTree>
+    <p:extLst>
+      <p:ext uri="{BB962C8B-B14F-4D97-AF65-F5344CB8AC3E}">
+        <p14:creationId xmlns:p14="http://schemas.microsoft.com/office/powerpoint/2010/main" val="2526147619"/>
+      </p:ext>
+    </p:extLst>
   </p:cSld>
   <p:clrMapOvr>
     <a:masterClrMapping/>
@@ -3831,7 +3126,7 @@
       </p:sp>
       <p:pic>
         <p:nvPicPr>
-          <p:cNvPr id="8" name="Image 0" descr="preencoded.png">    </p:cNvPr>
+          <p:cNvPr id="8" name="Image 0" descr="preencoded.png"/>
           <p:cNvPicPr>
             <a:picLocks noChangeAspect="1"/>
           </p:cNvPicPr>
@@ -3855,7 +3150,7 @@
       </p:pic>
       <p:pic>
         <p:nvPicPr>
-          <p:cNvPr id="9" name="Image 1" descr="preencoded.png">    </p:cNvPr>
+          <p:cNvPr id="9" name="Image 1" descr="preencoded.png"/>
           <p:cNvPicPr>
             <a:picLocks noChangeAspect="1"/>
           </p:cNvPicPr>
@@ -3926,7 +3221,7 @@
       </p:sp>
       <p:pic>
         <p:nvPicPr>
-          <p:cNvPr id="12" name="Image 2" descr="preencoded.png">    </p:cNvPr>
+          <p:cNvPr id="12" name="Image 2" descr="preencoded.png"/>
           <p:cNvPicPr>
             <a:picLocks noChangeAspect="1"/>
           </p:cNvPicPr>
@@ -4478,7 +3773,7 @@
       </p:sp>
       <p:pic>
         <p:nvPicPr>
-          <p:cNvPr id="26" name="Image 3" descr="preencoded.png">    </p:cNvPr>
+          <p:cNvPr id="26" name="Image 3" descr="preencoded.png"/>
           <p:cNvPicPr>
             <a:picLocks noChangeAspect="1"/>
           </p:cNvPicPr>
@@ -5030,7 +4325,7 @@
       </p:sp>
       <p:pic>
         <p:nvPicPr>
-          <p:cNvPr id="40" name="Image 4" descr="preencoded.png">    </p:cNvPr>
+          <p:cNvPr id="40" name="Image 4" descr="preencoded.png"/>
           <p:cNvPicPr>
             <a:picLocks noChangeAspect="1"/>
           </p:cNvPicPr>
@@ -5843,7 +5138,7 @@
                 <a:ea typeface="Calibri" pitchFamily="34" charset="-122"/>
                 <a:cs typeface="Calibri" pitchFamily="34" charset="-120"/>
               </a:rPr>
-              <a:t>01  </a:t>
+              <a:t xml:space="preserve">01  </a:t>
             </a:r>
             <a:pPr indent="0" marL="0">
               <a:buNone/>
@@ -5871,7 +5166,7 @@
                 <a:ea typeface="Calibri" pitchFamily="34" charset="-122"/>
                 <a:cs typeface="Calibri" pitchFamily="34" charset="-120"/>
               </a:rPr>
-              <a:t>   One task, one prompt</a:t>
+              <a:t xml:space="preserve">   One task, one prompt</a:t>
             </a:r>
             <a:endParaRPr lang="en-US" sz="2000" dirty="0"/>
           </a:p>
@@ -6059,7 +5354,7 @@
                 <a:ea typeface="Calibri" pitchFamily="34" charset="-122"/>
                 <a:cs typeface="Calibri" pitchFamily="34" charset="-120"/>
               </a:rPr>
-              <a:t>02  </a:t>
+              <a:t xml:space="preserve">02  </a:t>
             </a:r>
             <a:pPr indent="0" marL="0">
               <a:buNone/>
@@ -6087,7 +5382,7 @@
                 <a:ea typeface="Calibri" pitchFamily="34" charset="-122"/>
                 <a:cs typeface="Calibri" pitchFamily="34" charset="-120"/>
               </a:rPr>
-              <a:t>   Define constraints and versions</a:t>
+              <a:t xml:space="preserve">   Define constraints and versions</a:t>
             </a:r>
             <a:endParaRPr lang="en-US" sz="2000" dirty="0"/>
           </a:p>
@@ -6275,7 +5570,7 @@
                 <a:ea typeface="Calibri" pitchFamily="34" charset="-122"/>
                 <a:cs typeface="Calibri" pitchFamily="34" charset="-120"/>
               </a:rPr>
-              <a:t>03  </a:t>
+              <a:t xml:space="preserve">03  </a:t>
             </a:r>
             <a:pPr indent="0" marL="0">
               <a:buNone/>
@@ -6303,7 +5598,7 @@
                 <a:ea typeface="Calibri" pitchFamily="34" charset="-122"/>
                 <a:cs typeface="Calibri" pitchFamily="34" charset="-120"/>
               </a:rPr>
-              <a:t>   Protect the context window</a:t>
+              <a:t xml:space="preserve">   Protect the context window</a:t>
             </a:r>
             <a:endParaRPr lang="en-US" sz="2000" dirty="0"/>
           </a:p>
@@ -6491,7 +5786,7 @@
                 <a:ea typeface="Calibri" pitchFamily="34" charset="-122"/>
                 <a:cs typeface="Calibri" pitchFamily="34" charset="-120"/>
               </a:rPr>
-              <a:t>04  </a:t>
+              <a:t xml:space="preserve">04  </a:t>
             </a:r>
             <a:pPr indent="0" marL="0">
               <a:buNone/>
@@ -6519,7 +5814,7 @@
                 <a:ea typeface="Calibri" pitchFamily="34" charset="-122"/>
                 <a:cs typeface="Calibri" pitchFamily="34" charset="-120"/>
               </a:rPr>
-              <a:t>   Ground the AI with open files</a:t>
+              <a:t xml:space="preserve">   Ground the AI with open files</a:t>
             </a:r>
             <a:endParaRPr lang="en-US" sz="2000" dirty="0"/>
           </a:p>
@@ -6912,7 +6207,7 @@
                 <a:ea typeface="Calibri" pitchFamily="34" charset="-122"/>
                 <a:cs typeface="Calibri" pitchFamily="34" charset="-120"/>
               </a:rPr>
-              <a:t>  Hands-on Labs</a:t>
+              <a:t xml:space="preserve">  Hands-on Labs</a:t>
             </a:r>
             <a:endParaRPr lang="en-US" sz="1400" dirty="0"/>
           </a:p>
@@ -7273,7 +6568,7 @@
                 <a:ea typeface="Calibri" pitchFamily="34" charset="-122"/>
                 <a:cs typeface="Calibri" pitchFamily="34" charset="-120"/>
               </a:rPr>
-              <a:t>  Structured Modules</a:t>
+              <a:t xml:space="preserve">  Structured Modules</a:t>
             </a:r>
             <a:endParaRPr lang="en-US" sz="1400" dirty="0"/>
           </a:p>

</xml_diff>